<commit_message>
Week 6: evaluation harness and baseline Random Forest and SVM on optical-only and SAR-only features
</commit_message>
<xml_diff>
--- a/Mid_Sem_Presentation/Mid_Sem_Presentation.pptx
+++ b/Mid_Sem_Presentation/Mid_Sem_Presentation.pptx
@@ -5,22 +5,22 @@
     <p:sldMasterId id="2147483648" r:id="rId1"/>
   </p:sldMasterIdLst>
   <p:notesMasterIdLst>
-    <p:notesMasterId r:id="rId29"/>
+    <p:notesMasterId r:id="rId12"/>
   </p:notesMasterIdLst>
   <p:handoutMasterIdLst>
-    <p:handoutMasterId r:id="rId30"/>
+    <p:handoutMasterId r:id="rId13"/>
   </p:handoutMasterIdLst>
   <p:sldIdLst>
-    <p:sldId id="256" r:id="rId9"/>
-    <p:sldId id="257" r:id="rId10"/>
-    <p:sldId id="258" r:id="rId11"/>
-    <p:sldId id="259" r:id="rId12"/>
-    <p:sldId id="260" r:id="rId13"/>
-    <p:sldId id="261" r:id="rId14"/>
-    <p:sldId id="262" r:id="rId15"/>
-    <p:sldId id="263" r:id="rId16"/>
-    <p:sldId id="264" r:id="rId17"/>
-    <p:sldId id="265" r:id="rId18"/>
+    <p:sldId id="256" r:id="rId2"/>
+    <p:sldId id="257" r:id="rId3"/>
+    <p:sldId id="258" r:id="rId4"/>
+    <p:sldId id="259" r:id="rId5"/>
+    <p:sldId id="260" r:id="rId6"/>
+    <p:sldId id="261" r:id="rId7"/>
+    <p:sldId id="262" r:id="rId8"/>
+    <p:sldId id="263" r:id="rId9"/>
+    <p:sldId id="264" r:id="rId10"/>
+    <p:sldId id="265" r:id="rId11"/>
   </p:sldIdLst>
   <p:sldSz cx="12192000" cy="6858000"/>
   <p:notesSz cx="6858000" cy="12192000"/>
@@ -3731,18 +3731,55 @@
       </pc:sldChg>
     </pc:docChg>
   </pc:docChgLst>
+  <pc:docChgLst>
+    <pc:chgData name="Het  Patel" userId="33441a96-4037-441c-b3ff-fda27bc877de" providerId="ADAL" clId="{65E99360-3A3C-4A38-81BA-DE763BBCA250}"/>
+    <pc:docChg chg="undo custSel modSld">
+      <pc:chgData name="Het  Patel" userId="33441a96-4037-441c-b3ff-fda27bc877de" providerId="ADAL" clId="{65E99360-3A3C-4A38-81BA-DE763BBCA250}" dt="2026-10-12T02:40:54.336" v="63" actId="1037"/>
+      <pc:docMkLst>
+        <pc:docMk/>
+      </pc:docMkLst>
+      <pc:sldChg chg="modSp mod">
+        <pc:chgData name="Het  Patel" userId="33441a96-4037-441c-b3ff-fda27bc877de" providerId="ADAL" clId="{65E99360-3A3C-4A38-81BA-DE763BBCA250}" dt="2026-10-12T02:40:54.336" v="63" actId="1037"/>
+        <pc:sldMkLst>
+          <pc:docMk/>
+          <pc:sldMk cId="0" sldId="256"/>
+        </pc:sldMkLst>
+        <pc:spChg chg="mod">
+          <ac:chgData name="Het  Patel" userId="33441a96-4037-441c-b3ff-fda27bc877de" providerId="ADAL" clId="{65E99360-3A3C-4A38-81BA-DE763BBCA250}" dt="2026-10-12T02:40:54.336" v="63" actId="1037"/>
+          <ac:spMkLst>
+            <pc:docMk/>
+            <pc:sldMk cId="0" sldId="256"/>
+            <ac:spMk id="6" creationId="{00000000-0000-0000-0000-000000000000}"/>
+          </ac:spMkLst>
+        </pc:spChg>
+        <pc:spChg chg="mod">
+          <ac:chgData name="Het  Patel" userId="33441a96-4037-441c-b3ff-fda27bc877de" providerId="ADAL" clId="{65E99360-3A3C-4A38-81BA-DE763BBCA250}" dt="2026-10-12T02:40:54.336" v="63" actId="1037"/>
+          <ac:spMkLst>
+            <pc:docMk/>
+            <pc:sldMk cId="0" sldId="256"/>
+            <ac:spMk id="7" creationId="{00000000-0000-0000-0000-000000000000}"/>
+          </ac:spMkLst>
+        </pc:spChg>
+      </pc:sldChg>
+    </pc:docChg>
+  </pc:docChgLst>
 </pc:chgInfo>
 </file>
 
 <file path=ppt/charts/chart1.xml><?xml version="1.0" encoding="utf-8"?>
-<c:chartSpace xmlns:c="http://schemas.openxmlformats.org/drawingml/2006/chart" xmlns:a="http://schemas.openxmlformats.org/drawingml/2006/main" xmlns:r="http://schemas.openxmlformats.org/officeDocument/2006/relationships">
+<c:chartSpace xmlns:c="http://schemas.openxmlformats.org/drawingml/2006/chart" xmlns:a="http://schemas.openxmlformats.org/drawingml/2006/main" xmlns:r="http://schemas.openxmlformats.org/officeDocument/2006/relationships" xmlns:c16r2="http://schemas.microsoft.com/office/drawing/2015/06/chart">
   <c:date1904 val="0"/>
+  <c:lang val="en-US"/>
+  <c:roundedCorners val="1"/>
+  <c:style val="2"/>
   <c:chart>
     <c:autoTitleDeleted val="1"/>
     <c:plotArea>
+      <c:layout/>
       <c:barChart>
         <c:barDir val="col"/>
         <c:grouping val="stacked"/>
+        <c:varyColors val="1"/>
         <c:ser>
           <c:idx val="0"/>
           <c:order val="0"/>
@@ -3762,6 +3799,44 @@
               <a:srgbClr val="800000"/>
             </a:solidFill>
           </c:spPr>
+          <c:invertIfNegative val="1"/>
+          <c:dLbls>
+            <c:spPr>
+              <a:noFill/>
+              <a:ln>
+                <a:noFill/>
+              </a:ln>
+              <a:effectLst/>
+            </c:spPr>
+            <c:txPr>
+              <a:bodyPr/>
+              <a:lstStyle/>
+              <a:p>
+                <a:pPr>
+                  <a:defRPr sz="1600">
+                    <a:solidFill>
+                      <a:srgbClr val="FFFFFF"/>
+                    </a:solidFill>
+                    <a:latin typeface="Times New Roman"/>
+                  </a:defRPr>
+                </a:pPr>
+                <a:endParaRPr lang="en-US"/>
+              </a:p>
+            </c:txPr>
+            <c:dLblPos val="ctr"/>
+            <c:showLegendKey val="0"/>
+            <c:showVal val="1"/>
+            <c:showCatName val="0"/>
+            <c:showSerName val="0"/>
+            <c:showPercent val="0"/>
+            <c:showBubbleSize val="0"/>
+            <c:showLeaderLines val="0"/>
+            <c:extLst>
+              <c:ext xmlns:c15="http://schemas.microsoft.com/office/drawing/2012/chart" uri="{CE6537A1-D6FC-4f65-9D91-7224C49458BB}">
+                <c15:showLeaderLines val="0"/>
+              </c:ext>
+            </c:extLst>
+          </c:dLbls>
           <c:cat>
             <c:strRef>
               <c:f>Sheet1!$A$2:$A$4</c:f>
@@ -3797,6 +3872,20 @@
               </c:numCache>
             </c:numRef>
           </c:val>
+          <c:extLst>
+            <c:ext xmlns:c14="http://schemas.microsoft.com/office/drawing/2007/8/2/chart" uri="{6F2FDCE9-48DA-4B69-8628-5D25D57E5C99}">
+              <c14:invertSolidFillFmt>
+                <c14:spPr xmlns:c14="http://schemas.microsoft.com/office/drawing/2007/8/2/chart">
+                  <a:solidFill>
+                    <a:srgbClr val="FFFFFF"/>
+                  </a:solidFill>
+                </c14:spPr>
+              </c14:invertSolidFillFmt>
+            </c:ext>
+            <c:ext xmlns:c16="http://schemas.microsoft.com/office/drawing/2014/chart" uri="{C3380CC4-5D6E-409C-BE32-E72D297353CC}">
+              <c16:uniqueId val="{00000000-DB79-4CB6-A8B9-0047D20DC60C}"/>
+            </c:ext>
+          </c:extLst>
         </c:ser>
         <c:ser>
           <c:idx val="1"/>
@@ -3817,6 +3906,44 @@
               <a:srgbClr val="717171"/>
             </a:solidFill>
           </c:spPr>
+          <c:invertIfNegative val="1"/>
+          <c:dLbls>
+            <c:spPr>
+              <a:noFill/>
+              <a:ln>
+                <a:noFill/>
+              </a:ln>
+              <a:effectLst/>
+            </c:spPr>
+            <c:txPr>
+              <a:bodyPr/>
+              <a:lstStyle/>
+              <a:p>
+                <a:pPr>
+                  <a:defRPr sz="1600">
+                    <a:solidFill>
+                      <a:srgbClr val="FFFFFF"/>
+                    </a:solidFill>
+                    <a:latin typeface="Times New Roman"/>
+                  </a:defRPr>
+                </a:pPr>
+                <a:endParaRPr lang="en-US"/>
+              </a:p>
+            </c:txPr>
+            <c:dLblPos val="ctr"/>
+            <c:showLegendKey val="0"/>
+            <c:showVal val="1"/>
+            <c:showCatName val="0"/>
+            <c:showSerName val="0"/>
+            <c:showPercent val="0"/>
+            <c:showBubbleSize val="0"/>
+            <c:showLeaderLines val="0"/>
+            <c:extLst>
+              <c:ext xmlns:c15="http://schemas.microsoft.com/office/drawing/2012/chart" uri="{CE6537A1-D6FC-4f65-9D91-7224C49458BB}">
+                <c15:showLeaderLines val="0"/>
+              </c:ext>
+            </c:extLst>
+          </c:dLbls>
           <c:cat>
             <c:strRef>
               <c:f>Sheet1!$A$2:$A$4</c:f>
@@ -3852,22 +3979,22 @@
               </c:numCache>
             </c:numRef>
           </c:val>
-        </c:ser>
-        <c:dLbls>
-          <c:txPr>
-            <a:bodyPr/>
-            <a:lstStyle/>
-            <a:p>
-              <a:pPr>
-                <a:defRPr sz="1600">
+          <c:extLst>
+            <c:ext xmlns:c14="http://schemas.microsoft.com/office/drawing/2007/8/2/chart" uri="{6F2FDCE9-48DA-4B69-8628-5D25D57E5C99}">
+              <c14:invertSolidFillFmt>
+                <c14:spPr xmlns:c14="http://schemas.microsoft.com/office/drawing/2007/8/2/chart">
                   <a:solidFill>
                     <a:srgbClr val="FFFFFF"/>
                   </a:solidFill>
-                  <a:latin typeface="Times New Roman"/>
-                </a:defRPr>
-              </a:pPr>
-            </a:p>
-          </c:txPr>
+                </c14:spPr>
+              </c14:invertSolidFillFmt>
+            </c:ext>
+            <c:ext xmlns:c16="http://schemas.microsoft.com/office/drawing/2014/chart" uri="{C3380CC4-5D6E-409C-BE32-E72D297353CC}">
+              <c16:uniqueId val="{00000001-DB79-4CB6-A8B9-0047D20DC60C}"/>
+            </c:ext>
+          </c:extLst>
+        </c:ser>
+        <c:dLbls>
           <c:dLblPos val="ctr"/>
           <c:showLegendKey val="0"/>
           <c:showVal val="1"/>
@@ -3875,7 +4002,6 @@
           <c:showSerName val="0"/>
           <c:showPercent val="0"/>
           <c:showBubbleSize val="0"/>
-          <c:showLeaderLines val="1"/>
         </c:dLbls>
         <c:gapWidth val="60"/>
         <c:overlap val="100"/>
@@ -3889,6 +4015,7 @@
         </c:scaling>
         <c:delete val="0"/>
         <c:axPos val="b"/>
+        <c:numFmt formatCode="General" sourceLinked="0"/>
         <c:majorTickMark val="out"/>
         <c:minorTickMark val="none"/>
         <c:tickLblPos val="nextTo"/>
@@ -3899,6 +4026,7 @@
             <a:pPr>
               <a:defRPr sz="1600"/>
             </a:pPr>
+            <a:endParaRPr lang="en-US"/>
           </a:p>
         </c:txPr>
         <c:crossAx val="-2113994440"/>
@@ -3911,7 +4039,8 @@
       <c:valAx>
         <c:axId val="-2113994440"/>
         <c:scaling>
-          <c:max val="100.0"/>
+          <c:orientation val="minMax"/>
+          <c:max val="100"/>
         </c:scaling>
         <c:delete val="0"/>
         <c:axPos val="l"/>
@@ -3924,6 +4053,7 @@
             </a:ln>
           </c:spPr>
         </c:majorGridlines>
+        <c:numFmt formatCode="General" sourceLinked="1"/>
         <c:majorTickMark val="out"/>
         <c:minorTickMark val="none"/>
         <c:tickLblPos val="nextTo"/>
@@ -3939,10 +4069,12 @@
             <a:pPr>
               <a:defRPr sz="1400"/>
             </a:pPr>
+            <a:endParaRPr lang="en-US"/>
           </a:p>
         </c:txPr>
         <c:crossAx val="-2068027336"/>
         <c:crosses val="autoZero"/>
+        <c:crossBetween val="between"/>
       </c:valAx>
     </c:plotArea>
     <c:legend>
@@ -3957,10 +4089,13 @@
               <a:latin typeface="Times New Roman"/>
             </a:defRPr>
           </a:pPr>
+          <a:endParaRPr lang="en-US"/>
         </a:p>
       </c:txPr>
     </c:legend>
+    <c:plotVisOnly val="1"/>
     <c:dispBlanksAs val="gap"/>
+    <c:showDLblsOverMax val="1"/>
   </c:chart>
   <c:txPr>
     <a:bodyPr/>
@@ -3981,14 +4116,19 @@
 </file>
 
 <file path=ppt/charts/chart2.xml><?xml version="1.0" encoding="utf-8"?>
-<c:chartSpace xmlns:c="http://schemas.openxmlformats.org/drawingml/2006/chart" xmlns:a="http://schemas.openxmlformats.org/drawingml/2006/main" xmlns:r="http://schemas.openxmlformats.org/officeDocument/2006/relationships">
+<c:chartSpace xmlns:c="http://schemas.openxmlformats.org/drawingml/2006/chart" xmlns:a="http://schemas.openxmlformats.org/drawingml/2006/main" xmlns:r="http://schemas.openxmlformats.org/officeDocument/2006/relationships" xmlns:c16r2="http://schemas.microsoft.com/office/drawing/2015/06/chart">
   <c:date1904 val="0"/>
+  <c:lang val="en-US"/>
+  <c:roundedCorners val="1"/>
+  <c:style val="2"/>
   <c:chart>
     <c:autoTitleDeleted val="1"/>
     <c:plotArea>
+      <c:layout/>
       <c:barChart>
         <c:barDir val="col"/>
         <c:grouping val="clustered"/>
+        <c:varyColors val="1"/>
         <c:ser>
           <c:idx val="0"/>
           <c:order val="0"/>
@@ -4008,6 +4148,42 @@
               <a:srgbClr val="800000"/>
             </a:solidFill>
           </c:spPr>
+          <c:invertIfNegative val="1"/>
+          <c:dLbls>
+            <c:numFmt formatCode="0" sourceLinked="0"/>
+            <c:spPr>
+              <a:noFill/>
+              <a:ln>
+                <a:noFill/>
+              </a:ln>
+              <a:effectLst/>
+            </c:spPr>
+            <c:txPr>
+              <a:bodyPr/>
+              <a:lstStyle/>
+              <a:p>
+                <a:pPr>
+                  <a:defRPr sz="1600">
+                    <a:latin typeface="Times New Roman"/>
+                  </a:defRPr>
+                </a:pPr>
+                <a:endParaRPr lang="en-US"/>
+              </a:p>
+            </c:txPr>
+            <c:dLblPos val="outEnd"/>
+            <c:showLegendKey val="0"/>
+            <c:showVal val="1"/>
+            <c:showCatName val="0"/>
+            <c:showSerName val="0"/>
+            <c:showPercent val="0"/>
+            <c:showBubbleSize val="0"/>
+            <c:showLeaderLines val="0"/>
+            <c:extLst>
+              <c:ext xmlns:c15="http://schemas.microsoft.com/office/drawing/2012/chart" uri="{CE6537A1-D6FC-4f65-9D91-7224C49458BB}">
+                <c15:showLeaderLines val="0"/>
+              </c:ext>
+            </c:extLst>
+          </c:dLbls>
           <c:cat>
             <c:strRef>
               <c:f>Sheet1!$A$2:$A$4</c:f>
@@ -4043,6 +4219,20 @@
               </c:numCache>
             </c:numRef>
           </c:val>
+          <c:extLst>
+            <c:ext xmlns:c14="http://schemas.microsoft.com/office/drawing/2007/8/2/chart" uri="{6F2FDCE9-48DA-4B69-8628-5D25D57E5C99}">
+              <c14:invertSolidFillFmt>
+                <c14:spPr xmlns:c14="http://schemas.microsoft.com/office/drawing/2007/8/2/chart">
+                  <a:solidFill>
+                    <a:srgbClr val="FFFFFF"/>
+                  </a:solidFill>
+                </c14:spPr>
+              </c14:invertSolidFillFmt>
+            </c:ext>
+            <c:ext xmlns:c16="http://schemas.microsoft.com/office/drawing/2014/chart" uri="{C3380CC4-5D6E-409C-BE32-E72D297353CC}">
+              <c16:uniqueId val="{00000000-DA13-463C-A48D-49D915018F1F}"/>
+            </c:ext>
+          </c:extLst>
         </c:ser>
         <c:ser>
           <c:idx val="1"/>
@@ -4063,6 +4253,42 @@
               <a:srgbClr val="717171"/>
             </a:solidFill>
           </c:spPr>
+          <c:invertIfNegative val="1"/>
+          <c:dLbls>
+            <c:numFmt formatCode="0" sourceLinked="0"/>
+            <c:spPr>
+              <a:noFill/>
+              <a:ln>
+                <a:noFill/>
+              </a:ln>
+              <a:effectLst/>
+            </c:spPr>
+            <c:txPr>
+              <a:bodyPr/>
+              <a:lstStyle/>
+              <a:p>
+                <a:pPr>
+                  <a:defRPr sz="1600">
+                    <a:latin typeface="Times New Roman"/>
+                  </a:defRPr>
+                </a:pPr>
+                <a:endParaRPr lang="en-US"/>
+              </a:p>
+            </c:txPr>
+            <c:dLblPos val="outEnd"/>
+            <c:showLegendKey val="0"/>
+            <c:showVal val="1"/>
+            <c:showCatName val="0"/>
+            <c:showSerName val="0"/>
+            <c:showPercent val="0"/>
+            <c:showBubbleSize val="0"/>
+            <c:showLeaderLines val="0"/>
+            <c:extLst>
+              <c:ext xmlns:c15="http://schemas.microsoft.com/office/drawing/2012/chart" uri="{CE6537A1-D6FC-4f65-9D91-7224C49458BB}">
+                <c15:showLeaderLines val="0"/>
+              </c:ext>
+            </c:extLst>
+          </c:dLbls>
           <c:cat>
             <c:strRef>
               <c:f>Sheet1!$A$2:$A$4</c:f>
@@ -4098,20 +4324,22 @@
               </c:numCache>
             </c:numRef>
           </c:val>
+          <c:extLst>
+            <c:ext xmlns:c14="http://schemas.microsoft.com/office/drawing/2007/8/2/chart" uri="{6F2FDCE9-48DA-4B69-8628-5D25D57E5C99}">
+              <c14:invertSolidFillFmt>
+                <c14:spPr xmlns:c14="http://schemas.microsoft.com/office/drawing/2007/8/2/chart">
+                  <a:solidFill>
+                    <a:srgbClr val="FFFFFF"/>
+                  </a:solidFill>
+                </c14:spPr>
+              </c14:invertSolidFillFmt>
+            </c:ext>
+            <c:ext xmlns:c16="http://schemas.microsoft.com/office/drawing/2014/chart" uri="{C3380CC4-5D6E-409C-BE32-E72D297353CC}">
+              <c16:uniqueId val="{00000001-DA13-463C-A48D-49D915018F1F}"/>
+            </c:ext>
+          </c:extLst>
         </c:ser>
         <c:dLbls>
-          <c:numFmt formatCode="0" sourceLinked="0"/>
-          <c:txPr>
-            <a:bodyPr/>
-            <a:lstStyle/>
-            <a:p>
-              <a:pPr>
-                <a:defRPr sz="1600">
-                  <a:latin typeface="Times New Roman"/>
-                </a:defRPr>
-              </a:pPr>
-            </a:p>
-          </c:txPr>
           <c:dLblPos val="outEnd"/>
           <c:showLegendKey val="0"/>
           <c:showVal val="1"/>
@@ -4119,7 +4347,6 @@
           <c:showSerName val="0"/>
           <c:showPercent val="0"/>
           <c:showBubbleSize val="0"/>
-          <c:showLeaderLines val="1"/>
         </c:dLbls>
         <c:gapWidth val="70"/>
         <c:overlap val="-5"/>
@@ -4133,6 +4360,7 @@
         </c:scaling>
         <c:delete val="0"/>
         <c:axPos val="b"/>
+        <c:numFmt formatCode="General" sourceLinked="0"/>
         <c:majorTickMark val="out"/>
         <c:minorTickMark val="none"/>
         <c:tickLblPos val="nextTo"/>
@@ -4143,6 +4371,7 @@
             <a:pPr>
               <a:defRPr sz="1600"/>
             </a:pPr>
+            <a:endParaRPr lang="en-US"/>
           </a:p>
         </c:txPr>
         <c:crossAx val="-2113994440"/>
@@ -4155,7 +4384,8 @@
       <c:valAx>
         <c:axId val="-2113994440"/>
         <c:scaling>
-          <c:max val="500.0"/>
+          <c:orientation val="minMax"/>
+          <c:max val="500"/>
         </c:scaling>
         <c:delete val="0"/>
         <c:axPos val="l"/>
@@ -4168,6 +4398,7 @@
             </a:ln>
           </c:spPr>
         </c:majorGridlines>
+        <c:numFmt formatCode="General" sourceLinked="1"/>
         <c:majorTickMark val="out"/>
         <c:minorTickMark val="none"/>
         <c:tickLblPos val="nextTo"/>
@@ -4183,10 +4414,12 @@
             <a:pPr>
               <a:defRPr sz="1400"/>
             </a:pPr>
+            <a:endParaRPr lang="en-US"/>
           </a:p>
         </c:txPr>
         <c:crossAx val="-2068027336"/>
         <c:crosses val="autoZero"/>
+        <c:crossBetween val="between"/>
       </c:valAx>
     </c:plotArea>
     <c:legend>
@@ -4201,10 +4434,13 @@
               <a:latin typeface="Times New Roman"/>
             </a:defRPr>
           </a:pPr>
+          <a:endParaRPr lang="en-US"/>
         </a:p>
       </c:txPr>
     </c:legend>
+    <c:plotVisOnly val="1"/>
     <c:dispBlanksAs val="gap"/>
+    <c:showDLblsOverMax val="1"/>
   </c:chart>
   <c:txPr>
     <a:bodyPr/>
@@ -4318,7 +4554,7 @@
           <a:p>
             <a:fld id="{43AD544C-77BC-429F-B9EC-D417B112CDA0}" type="datetimeFigureOut">
               <a:rPr lang="en-IN" smtClean="0"/>
-              <a:t>12-07-2026</a:t>
+              <a:t>12-10-2026</a:t>
             </a:fld>
             <a:endParaRPr lang="en-IN"/>
           </a:p>
@@ -4544,7 +4780,7 @@
 </file>
 
 <file path=ppt/notesSlides/notesSlide1.xml><?xml version="1.0" encoding="utf-8"?>
-<p:notes xmlns:a="http://schemas.openxmlformats.org/drawingml/2006/main" xmlns:p="http://schemas.openxmlformats.org/presentationml/2006/main" xmlns:r="http://schemas.openxmlformats.org/officeDocument/2006/relationships">
+<p:notes xmlns:a="http://schemas.openxmlformats.org/drawingml/2006/main" xmlns:r="http://schemas.openxmlformats.org/officeDocument/2006/relationships" xmlns:p="http://schemas.openxmlformats.org/presentationml/2006/main">
   <p:cSld>
     <p:spTree>
       <p:nvGrpSpPr>
@@ -4579,7 +4815,9 @@
               <a:t>TIME: 30 seconds</a:t>
             </a:r>
           </a:p>
-          <a:p/>
+          <a:p>
+            <a:endParaRPr/>
+          </a:p>
           <a:p>
             <a:r>
               <a:t>SAY:</a:t>
@@ -4590,19 +4828,25 @@
               <a:t>Good morning. We are Group 3 of Project 19 in ECE 501, Digital Image Processing. I am Het Patel, and with me are Dhairya Shah, Jay Daftari and Hiya Soni.</a:t>
             </a:r>
           </a:p>
-          <a:p/>
+          <a:p>
+            <a:endParaRPr/>
+          </a:p>
           <a:p>
             <a:r>
               <a:t>Our project is about one question: can we tell which crop grows in a field if we look at it with two different kinds of satellite image together? The title says it in short. SAR is radar imaging. Optical is normal sunlight imaging. Fusion means combining what we learn from both. Classification means the output is a label, here corn, soybean or wheat. YieldSAT is the dataset we use.</a:t>
             </a:r>
           </a:p>
-          <a:p/>
+          <a:p>
+            <a:endParaRPr/>
+          </a:p>
           <a:p>
             <a:r>
               <a:t>Today we cover only the first half of the semester, which is the data and the processing pipeline. The classifier comes in the second half.</a:t>
             </a:r>
           </a:p>
-          <a:p/>
+          <a:p>
+            <a:endParaRPr/>
+          </a:p>
           <a:p>
             <a:r>
               <a:t>TRANSITION: Let me start with why this matters.</a:t>
@@ -4619,7 +4863,7 @@
 </file>
 
 <file path=ppt/notesSlides/notesSlide10.xml><?xml version="1.0" encoding="utf-8"?>
-<p:notes xmlns:a="http://schemas.openxmlformats.org/drawingml/2006/main" xmlns:p="http://schemas.openxmlformats.org/presentationml/2006/main" xmlns:r="http://schemas.openxmlformats.org/officeDocument/2006/relationships">
+<p:notes xmlns:a="http://schemas.openxmlformats.org/drawingml/2006/main" xmlns:r="http://schemas.openxmlformats.org/officeDocument/2006/relationships" xmlns:p="http://schemas.openxmlformats.org/presentationml/2006/main">
   <p:cSld>
     <p:spTree>
       <p:nvGrpSpPr>
@@ -4654,7 +4898,9 @@
               <a:t>TIME: 45 seconds</a:t>
             </a:r>
           </a:p>
-          <a:p/>
+          <a:p>
+            <a:endParaRPr/>
+          </a:p>
           <a:p>
             <a:r>
               <a:t>SAY (each member introduces their own line, or one person reads it):</a:t>
@@ -4680,13 +4926,17 @@
               <a:t>- Hiya Soni: the speckle test, the result figures and the field summary table.</a:t>
             </a:r>
           </a:p>
-          <a:p/>
+          <a:p>
+            <a:endParaRPr/>
+          </a:p>
           <a:p>
             <a:r>
               <a:t>NOTE FOR THE TEAM BEFORE PRESENTING: this split is a draft. Edit the slide so that it matches what each person actually did.</a:t>
             </a:r>
           </a:p>
-          <a:p/>
+          <a:p>
+            <a:endParaRPr/>
+          </a:p>
           <a:p>
             <a:r>
               <a:t>CLOSING:</a:t>
@@ -4697,7 +4947,9 @@
               <a:t>To summarise: the optical branch gives a clean composite and four indices, the SAR branch gives a filtered image on the same grid, and both ran on real data from all 1302 fields in the dataset check and on three fields end to end. Next is texture, a feature table and the classifiers. Thank you. We are happy to take questions.</a:t>
             </a:r>
           </a:p>
-          <a:p/>
+          <a:p>
+            <a:endParaRPr/>
+          </a:p>
           <a:p>
             <a:r>
               <a:t>LIKELY QUESTIONS:</a:t>
@@ -4734,7 +4986,7 @@
 </file>
 
 <file path=ppt/notesSlides/notesSlide2.xml><?xml version="1.0" encoding="utf-8"?>
-<p:notes xmlns:a="http://schemas.openxmlformats.org/drawingml/2006/main" xmlns:p="http://schemas.openxmlformats.org/presentationml/2006/main" xmlns:r="http://schemas.openxmlformats.org/officeDocument/2006/relationships">
+<p:notes xmlns:a="http://schemas.openxmlformats.org/drawingml/2006/main" xmlns:r="http://schemas.openxmlformats.org/officeDocument/2006/relationships" xmlns:p="http://schemas.openxmlformats.org/presentationml/2006/main">
   <p:cSld>
     <p:spTree>
       <p:nvGrpSpPr>
@@ -4769,7 +5021,9 @@
               <a:t>TIME: 1.5 minutes</a:t>
             </a:r>
           </a:p>
-          <a:p/>
+          <a:p>
+            <a:endParaRPr/>
+          </a:p>
           <a:p>
             <a:r>
               <a:t>SAY (flow: why crop type, why one sensor fails, why radar helps, what we ask):</a:t>
@@ -4780,49 +5034,65 @@
               <a:t>1. Why crop type. Knowing which crop grows where helps with farm planning and food security. A crop map tells planners what is planted and how much, over areas too large to visit on foot. Satellites are the only practical way to do this at scale.</a:t>
             </a:r>
           </a:p>
-          <a:p/>
+          <a:p>
+            <a:endParaRPr/>
+          </a:p>
           <a:p>
             <a:r>
               <a:t>2. Two kinds of satellite. Optical satellites such as Sentinel-2 are passive. They measure sunlight reflected from the ground, in colours our eyes see and in near-infrared. Healthy plants reflect strongly in near-infrared, so optical images tell us a lot about greenness. Radar satellites such as Sentinel-1 are active. They send their own microwave pulse and measure what comes back. They do not need sunlight.</a:t>
             </a:r>
           </a:p>
-          <a:p/>
+          <a:p>
+            <a:endParaRPr/>
+          </a:p>
           <a:p>
             <a:r>
               <a:t>3. The problem with optical, shown by our own data. This chart is from three real fields, one per crop. The grey part is the number of dates we had to drop because clouds or cloud shadow covered too much of the field. Corn keeps 52 of 96 dates, soybean 47 of 81, wheat 49 of 93. Added together that is 148 kept out of 270, about 55 percent kept, so about 45 percent lost. Note these are three fields only, so treat 55 percent as an indication, not a dataset-wide number.</a:t>
             </a:r>
           </a:p>
-          <a:p/>
+          <a:p>
+            <a:endParaRPr/>
+          </a:p>
           <a:p>
             <a:r>
               <a:t>4. Why radar helps. Radar waves pass through clouds, so a radar image exists even on the dates optical is blocked. It also responds to different things: the structure and moisture of the plants, not their colour. So the two sensors give two different views of the same field.</a:t>
             </a:r>
           </a:p>
-          <a:p/>
+          <a:p>
+            <a:endParaRPr/>
+          </a:p>
           <a:p>
             <a:r>
               <a:t>5. The catch. Radar images carry speckle, a grainy noise. We cannot use them raw, which is why a filter is part of our pipeline.</a:t>
             </a:r>
           </a:p>
-          <a:p/>
+          <a:p>
+            <a:endParaRPr/>
+          </a:p>
           <a:p>
             <a:r>
               <a:t>INFERENCE: Neither sensor is enough alone. Optical is rich but incomplete in time. Radar is complete in time but noisy. That is the reason to fuse them.</a:t>
             </a:r>
           </a:p>
-          <a:p/>
+          <a:p>
+            <a:endParaRPr/>
+          </a:p>
           <a:p>
             <a:r>
               <a:t>KPI THIS SLIDE SUPPORTS: fraction of dates kept by the cloud mask, about 55 percent.</a:t>
             </a:r>
           </a:p>
-          <a:p/>
+          <a:p>
+            <a:endParaRPr/>
+          </a:p>
           <a:p>
             <a:r>
               <a:t>IF ASKED: "Why not just wait for a clear day?" A crop grows on a schedule, and the clear days may fall outside the growth stage that separates crops.</a:t>
             </a:r>
           </a:p>
-          <a:p/>
+          <a:p>
+            <a:endParaRPr/>
+          </a:p>
           <a:p>
             <a:r>
               <a:t>TRANSITION: So the exact problem we are solving is the following.</a:t>
@@ -4839,7 +5109,7 @@
 </file>
 
 <file path=ppt/notesSlides/notesSlide3.xml><?xml version="1.0" encoding="utf-8"?>
-<p:notes xmlns:a="http://schemas.openxmlformats.org/drawingml/2006/main" xmlns:p="http://schemas.openxmlformats.org/presentationml/2006/main" xmlns:r="http://schemas.openxmlformats.org/officeDocument/2006/relationships">
+<p:notes xmlns:a="http://schemas.openxmlformats.org/drawingml/2006/main" xmlns:r="http://schemas.openxmlformats.org/officeDocument/2006/relationships" xmlns:p="http://schemas.openxmlformats.org/presentationml/2006/main">
   <p:cSld>
     <p:spTree>
       <p:nvGrpSpPr>
@@ -4874,7 +5144,9 @@
               <a:t>TIME: 1 minute</a:t>
             </a:r>
           </a:p>
-          <a:p/>
+          <a:p>
+            <a:endParaRPr/>
+          </a:p>
           <a:p>
             <a:r>
               <a:t>SAY:</a:t>
@@ -4885,7 +5157,9 @@
               <a:t>Our problem in two sentences. Given Sentinel-2 and Sentinel-1 images of the same field, predict whether it grows corn, soybean or wheat. And compare three settings: optical-only, SAR-only and fused features, using classical machine learning.</a:t>
             </a:r>
           </a:p>
-          <a:p/>
+          <a:p>
+            <a:endParaRPr/>
+          </a:p>
           <a:p>
             <a:r>
               <a:t>Words to explain:</a:t>
@@ -4906,19 +5180,25 @@
               <a:t>- Fused: the optical and SAR feature numbers joined into one vector per field.</a:t>
             </a:r>
           </a:p>
-          <a:p/>
+          <a:p>
+            <a:endParaRPr/>
+          </a:p>
           <a:p>
             <a:r>
               <a:t>The right-hand card is our scope today. For mid-sem we only built and tested the data pipeline, on three real fields from Argentina, plus a check of the whole dataset. The left card is what comes next. Our group was assigned Argentina and Brazil.</a:t>
             </a:r>
           </a:p>
-          <a:p/>
+          <a:p>
+            <a:endParaRPr/>
+          </a:p>
           <a:p>
             <a:r>
               <a:t>HONEST POINT: We have not trained a classifier yet. So we do not claim that fusion is better. That is what the second half will measure.</a:t>
             </a:r>
           </a:p>
-          <a:p/>
+          <a:p>
+            <a:endParaRPr/>
+          </a:p>
           <a:p>
             <a:r>
               <a:t>TRANSITION: Before the method, what does existing work give us?</a:t>
@@ -4935,7 +5215,7 @@
 </file>
 
 <file path=ppt/notesSlides/notesSlide4.xml><?xml version="1.0" encoding="utf-8"?>
-<p:notes xmlns:a="http://schemas.openxmlformats.org/drawingml/2006/main" xmlns:p="http://schemas.openxmlformats.org/presentationml/2006/main" xmlns:r="http://schemas.openxmlformats.org/officeDocument/2006/relationships">
+<p:notes xmlns:a="http://schemas.openxmlformats.org/drawingml/2006/main" xmlns:r="http://schemas.openxmlformats.org/officeDocument/2006/relationships" xmlns:p="http://schemas.openxmlformats.org/presentationml/2006/main">
   <p:cSld>
     <p:spTree>
       <p:nvGrpSpPr>
@@ -4970,7 +5250,9 @@
               <a:t>TIME: 1 minute</a:t>
             </a:r>
           </a:p>
-          <a:p/>
+          <a:p>
+            <a:endParaRPr/>
+          </a:p>
           <a:p>
             <a:r>
               <a:t>SAY:</a:t>
@@ -4981,7 +5263,9 @@
               <a:t>We rely on six sources, and each one maps to a part of our pipeline. I will go through the table by its last column.</a:t>
             </a:r>
           </a:p>
-          <a:p/>
+          <a:p>
+            <a:endParaRPr/>
+          </a:p>
           <a:p>
             <a:r>
               <a:t>[1] Miranda and colleagues, YieldSAT, CVPR 2026. This is our dataset. It is a multimodal benchmark with Sentinel-2 images and crop labels for many fields. Importantly, it has no radar data.</a:t>
@@ -5012,19 +5296,25 @@
               <a:t>[6] Haralick and colleagues, 1973. Gray level co-occurrence matrix texture features. This is planned for the second half.</a:t>
             </a:r>
           </a:p>
-          <a:p/>
+          <a:p>
+            <a:endParaRPr/>
+          </a:p>
           <a:p>
             <a:r>
               <a:t>THE GAP, the line at the bottom: YieldSAT does not contain radar, so the radar half of the project is built by us. That is a real piece of work, not just reading data that already exists.</a:t>
             </a:r>
           </a:p>
-          <a:p/>
+          <a:p>
+            <a:endParaRPr/>
+          </a:p>
           <a:p>
             <a:r>
               <a:t>IF ASKED about other fusion papers: our mid-sem report cites only these six, so I will say that a wider survey of fusion methods is part of the end-sem report.</a:t>
             </a:r>
           </a:p>
-          <a:p/>
+          <a:p>
+            <a:endParaRPr/>
+          </a:p>
           <a:p>
             <a:r>
               <a:t>TRANSITION: Now the data itself.</a:t>
@@ -5041,7 +5331,7 @@
 </file>
 
 <file path=ppt/notesSlides/notesSlide5.xml><?xml version="1.0" encoding="utf-8"?>
-<p:notes xmlns:a="http://schemas.openxmlformats.org/drawingml/2006/main" xmlns:p="http://schemas.openxmlformats.org/presentationml/2006/main" xmlns:r="http://schemas.openxmlformats.org/officeDocument/2006/relationships">
+<p:notes xmlns:a="http://schemas.openxmlformats.org/drawingml/2006/main" xmlns:r="http://schemas.openxmlformats.org/officeDocument/2006/relationships" xmlns:p="http://schemas.openxmlformats.org/presentationml/2006/main">
   <p:cSld>
     <p:spTree>
       <p:nvGrpSpPr>
@@ -5076,7 +5366,9 @@
               <a:t>TIME: 1 minute</a:t>
             </a:r>
           </a:p>
-          <a:p/>
+          <a:p>
+            <a:endParaRPr/>
+          </a:p>
           <a:p>
             <a:r>
               <a:t>SAY:</a:t>
@@ -5087,25 +5379,33 @@
               <a:t>First KPI: coverage. We scanned every field folder in our two countries. All 751 Argentina fields and all 551 Brazil fields loaded without errors, 1302 in total. The crop counts also match the YieldSAT paper. Argentina has 185 corn, 440 soybean and 126 wheat fields. Brazil has 118 corn, 293 soybean and 140 wheat.</a:t>
             </a:r>
           </a:p>
-          <a:p/>
+          <a:p>
+            <a:endParaRPr/>
+          </a:p>
           <a:p>
             <a:r>
               <a:t>What the chart tells us: the classes are not balanced. Soybean is the biggest class in both countries. So later we cannot trust accuracy alone. A model that always says soybean would already look decent. That is why we will also report F1-score and confusion matrices.</a:t>
             </a:r>
           </a:p>
-          <a:p/>
+          <a:p>
+            <a:endParaRPr/>
+          </a:p>
           <a:p>
             <a:r>
               <a:t>Dataset details: each field is a folder with Sentinel-2 images for every date between seeding and harvest. Each image has 12 bands at 10 metre resolution. Values are 16-bit integers, so we divide by 10000 to get reflectance. The value 0 means no data. Each date also has an SCL file, the scene classification layer, which gives a class for every pixel.</a:t>
             </a:r>
           </a:p>
-          <a:p/>
+          <a:p>
+            <a:endParaRPr/>
+          </a:p>
           <a:p>
             <a:r>
               <a:t>The issue we found: the image is a rectangle but the field is not. Corners outside the field have SCL class 0. Our first mask let these pixels through. We fixed it by keeping only an allow-list of usable classes. I mention it because it shows why we checked every field and not a sample.</a:t>
             </a:r>
           </a:p>
-          <a:p/>
+          <a:p>
+            <a:endParaRPr/>
+          </a:p>
           <a:p>
             <a:r>
               <a:t>TRANSITION: Next, how we turn these raw images into clean inputs.</a:t>
@@ -5122,7 +5422,7 @@
 </file>
 
 <file path=ppt/notesSlides/notesSlide6.xml><?xml version="1.0" encoding="utf-8"?>
-<p:notes xmlns:a="http://schemas.openxmlformats.org/drawingml/2006/main" xmlns:p="http://schemas.openxmlformats.org/presentationml/2006/main" xmlns:r="http://schemas.openxmlformats.org/officeDocument/2006/relationships">
+<p:notes xmlns:a="http://schemas.openxmlformats.org/drawingml/2006/main" xmlns:r="http://schemas.openxmlformats.org/officeDocument/2006/relationships" xmlns:p="http://schemas.openxmlformats.org/presentationml/2006/main">
   <p:cSld>
     <p:spTree>
       <p:nvGrpSpPr>
@@ -5157,13 +5457,17 @@
               <a:t>TIME: 1.5 minutes (this is the core method slide, go slowly)</a:t>
             </a:r>
           </a:p>
-          <a:p/>
+          <a:p>
+            <a:endParaRPr/>
+          </a:p>
           <a:p>
             <a:r>
               <a:t>SAY: two branches, same field, same grid.</a:t>
             </a:r>
           </a:p>
-          <a:p/>
+          <a:p>
+            <a:endParaRPr/>
+          </a:p>
           <a:p>
             <a:r>
               <a:t>OPTICAL BRANCH, left to right:</a:t>
@@ -5189,7 +5493,9 @@
               <a:t>4. Four indices. NDVI is near-infrared minus red over near-infrared plus red. Higher means greener. EVI is a corrected version that uses blue to reduce atmosphere and soil effects. GNDVI uses green instead of red and responds to chlorophyll. NDWI uses green and near-infrared and responds to water.</a:t>
             </a:r>
           </a:p>
-          <a:p/>
+          <a:p>
+            <a:endParaRPr/>
+          </a:p>
           <a:p>
             <a:r>
               <a:t>SAR BRANCH:</a:t>
@@ -5215,13 +5521,17 @@
               <a:t>4. Bilinear resampling onto the pixel grid of the YieldSAT field.</a:t>
             </a:r>
           </a:p>
-          <a:p/>
+          <a:p>
+            <a:endParaRPr/>
+          </a:p>
           <a:p>
             <a:r>
               <a:t>WHY THE LAST BOX MATTERS: after alignment, one optical pixel and one SAR pixel cover the same ground. Without this, we could not build one feature vector per field.</a:t>
             </a:r>
           </a:p>
-          <a:p/>
+          <a:p>
+            <a:endParaRPr/>
+          </a:p>
           <a:p>
             <a:r>
               <a:t>TRANSITION: Let us see what the pipeline produced on real fields.</a:t>
@@ -5238,7 +5548,7 @@
 </file>
 
 <file path=ppt/notesSlides/notesSlide7.xml><?xml version="1.0" encoding="utf-8"?>
-<p:notes xmlns:a="http://schemas.openxmlformats.org/drawingml/2006/main" xmlns:p="http://schemas.openxmlformats.org/presentationml/2006/main" xmlns:r="http://schemas.openxmlformats.org/officeDocument/2006/relationships">
+<p:notes xmlns:a="http://schemas.openxmlformats.org/drawingml/2006/main" xmlns:r="http://schemas.openxmlformats.org/officeDocument/2006/relationships" xmlns:p="http://schemas.openxmlformats.org/presentationml/2006/main">
   <p:cSld>
     <p:spTree>
       <p:nvGrpSpPr>
@@ -5273,7 +5583,9 @@
               <a:t>TIME: 1.5 minutes</a:t>
             </a:r>
           </a:p>
-          <a:p/>
+          <a:p>
+            <a:endParaRPr/>
+          </a:p>
           <a:p>
             <a:r>
               <a:t>SAY:</a:t>
@@ -5284,7 +5596,9 @@
               <a:t>We ran the full pipeline on one real Argentina field per crop. The figure shows the corn field in four panels. A is the cloud-free optical composite. B is NDVI, where green means higher values. C is the Sentinel-1 VV image as downloaded, and D is the same after the Lee filter and alignment. Look at C and D. The grain in C is speckle. In D the field texture is smoother but the dark patch at the bottom left is still there, so we removed noise and kept structure.</a:t>
             </a:r>
           </a:p>
-          <a:p/>
+          <a:p>
+            <a:endParaRPr/>
+          </a:p>
           <a:p>
             <a:r>
               <a:t>Now the table, with the KPIs:</a:t>
@@ -5315,7 +5629,9 @@
               <a:t>- VH: minus 17.50, minus 16.81 and minus 22.22 decibels.</a:t>
             </a:r>
           </a:p>
-          <a:p/>
+          <a:p>
+            <a:endParaRPr/>
+          </a:p>
           <a:p>
             <a:r>
               <a:t>INFERENCES, said carefully:</a:t>
@@ -5336,13 +5652,17 @@
               <a:t>3. NDVI values look low because the composite averages the whole season, including early growth. A peak-season composite should give higher values, and that is our next step.</a:t>
             </a:r>
           </a:p>
-          <a:p/>
+          <a:p>
+            <a:endParaRPr/>
+          </a:p>
           <a:p>
             <a:r>
               <a:t>LIMIT: one field per crop, one country. We cannot conclude that wheat always has lower VV. These are pipeline checks, not classification results.</a:t>
             </a:r>
           </a:p>
-          <a:p/>
+          <a:p>
+            <a:endParaRPr/>
+          </a:p>
           <a:p>
             <a:r>
               <a:t>TRANSITION: One more check, on the filter itself.</a:t>
@@ -5359,7 +5679,7 @@
 </file>
 
 <file path=ppt/notesSlides/notesSlide8.xml><?xml version="1.0" encoding="utf-8"?>
-<p:notes xmlns:a="http://schemas.openxmlformats.org/drawingml/2006/main" xmlns:p="http://schemas.openxmlformats.org/presentationml/2006/main" xmlns:r="http://schemas.openxmlformats.org/officeDocument/2006/relationships">
+<p:notes xmlns:a="http://schemas.openxmlformats.org/drawingml/2006/main" xmlns:r="http://schemas.openxmlformats.org/officeDocument/2006/relationships" xmlns:p="http://schemas.openxmlformats.org/presentationml/2006/main">
   <p:cSld>
     <p:spTree>
       <p:nvGrpSpPr>
@@ -5394,7 +5714,9 @@
               <a:t>TIME: 1 minute</a:t>
             </a:r>
           </a:p>
-          <a:p/>
+          <a:p>
+            <a:endParaRPr/>
+          </a:p>
           <a:p>
             <a:r>
               <a:t>SAY:</a:t>
@@ -5405,7 +5727,9 @@
               <a:t>How do we know the Lee filter works and does not just blur everything? We tested it on a real Sentinel-1 composite of a farmland area in Argentina, 112 by 113 pixels, built from 5 scenes. The figure shows VV and VH, raw on the left and filtered on the right.</a:t>
             </a:r>
           </a:p>
-          <a:p/>
+          <a:p>
+            <a:endParaRPr/>
+          </a:p>
           <a:p>
             <a:r>
               <a:t>Three numbers answer the question:</a:t>
@@ -5426,19 +5750,25 @@
               <a:t>3. Visually, the large structures remain and the grain is smoothed.</a:t>
             </a:r>
           </a:p>
-          <a:p/>
+          <a:p>
+            <a:endParaRPr/>
+          </a:p>
           <a:p>
             <a:r>
               <a:t>Why the standard deviation is a fair measure: speckle is random pixel-to-pixel variation, so reducing it lowers the standard deviation. The caution is that a field with real texture also has variation, so the drop is a proxy and not a perfect noise measure.</a:t>
             </a:r>
           </a:p>
-          <a:p/>
+          <a:p>
+            <a:endParaRPr/>
+          </a:p>
           <a:p>
             <a:r>
               <a:t>IF ASKED "why not a stronger filter or a bigger window": a larger window smooths more but blurs field borders. We picked 5 by 5 as the standard choice and may test other sizes if time allows. We have not yet compared filters.</a:t>
             </a:r>
           </a:p>
-          <a:p/>
+          <a:p>
+            <a:endParaRPr/>
+          </a:p>
           <a:p>
             <a:r>
               <a:t>TRANSITION: So what is next?</a:t>
@@ -5455,7 +5785,7 @@
 </file>
 
 <file path=ppt/notesSlides/notesSlide9.xml><?xml version="1.0" encoding="utf-8"?>
-<p:notes xmlns:a="http://schemas.openxmlformats.org/drawingml/2006/main" xmlns:p="http://schemas.openxmlformats.org/presentationml/2006/main" xmlns:r="http://schemas.openxmlformats.org/officeDocument/2006/relationships">
+<p:notes xmlns:a="http://schemas.openxmlformats.org/drawingml/2006/main" xmlns:r="http://schemas.openxmlformats.org/officeDocument/2006/relationships" xmlns:p="http://schemas.openxmlformats.org/presentationml/2006/main">
   <p:cSld>
     <p:spTree>
       <p:nvGrpSpPr>
@@ -5490,7 +5820,9 @@
               <a:t>TIME: 1 minute</a:t>
             </a:r>
           </a:p>
-          <a:p/>
+          <a:p>
+            <a:endParaRPr/>
+          </a:p>
           <a:p>
             <a:r>
               <a:t>SAY:</a:t>
@@ -5501,7 +5833,9 @@
               <a:t>Three steps lead to a classifier.</a:t>
             </a:r>
           </a:p>
-          <a:p/>
+          <a:p>
+            <a:endParaRPr/>
+          </a:p>
           <a:p>
             <a:r>
               <a:t>1. Features. We switch from a whole-season composite to a peak-season window, because that should give higher and more separable NDVI values. We also add GLCM texture features, which describe how gray levels are arranged in the image, such as contrast and homogeneity. This follows Haralick, reference 6.</a:t>
@@ -5517,25 +5851,33 @@
               <a:t>3. Models. We train Random Forest and SVM. Random Forest is a set of decision trees that vote. SVM finds a boundary that separates classes with the largest margin.</a:t>
             </a:r>
           </a:p>
-          <a:p/>
+          <a:p>
+            <a:endParaRPr/>
+          </a:p>
           <a:p>
             <a:r>
               <a:t>Evaluation. We compare optical-only, SAR-only and fused settings. The KPIs are accuracy, F1-score and the confusion matrix. Accuracy is the share of correct predictions. F1-score balances precision and recall per class, which matters because soybean dominates. The confusion matrix shows which crops get mixed up.</a:t>
             </a:r>
           </a:p>
-          <a:p/>
+          <a:p>
+            <a:endParaRPr/>
+          </a:p>
           <a:p>
             <a:r>
               <a:t>TARGET: end-sem presentation is around 16 November.</a:t>
             </a:r>
           </a:p>
-          <a:p/>
+          <a:p>
+            <a:endParaRPr/>
+          </a:p>
           <a:p>
             <a:r>
               <a:t>HONEST FRAMING: we do not yet know whether fusion beats optical-only. A possible outcome is that it does not help much. Either result is a valid finding.</a:t>
             </a:r>
           </a:p>
-          <a:p/>
+          <a:p>
+            <a:endParaRPr/>
+          </a:p>
           <a:p>
             <a:r>
               <a:t>TRANSITION: Finally, who did what.</a:t>
@@ -6629,7 +6971,7 @@
 </file>
 
 <file path=ppt/slides/slide1.xml><?xml version="1.0" encoding="utf-8"?>
-<p:sld xmlns:a="http://schemas.openxmlformats.org/drawingml/2006/main" xmlns:p="http://schemas.openxmlformats.org/presentationml/2006/main" xmlns:r="http://schemas.openxmlformats.org/officeDocument/2006/relationships">
+<p:sld xmlns:a="http://schemas.openxmlformats.org/drawingml/2006/main" xmlns:r="http://schemas.openxmlformats.org/officeDocument/2006/relationships" xmlns:p="http://schemas.openxmlformats.org/presentationml/2006/main">
   <p:cSld>
     <p:bg>
       <p:bgPr>
@@ -6645,7 +6987,14 @@
         <p:cNvGrpSpPr/>
         <p:nvPr/>
       </p:nvGrpSpPr>
-      <p:grpSpPr/>
+      <p:grpSpPr>
+        <a:xfrm>
+          <a:off x="0" y="0"/>
+          <a:ext cx="0" cy="0"/>
+          <a:chOff x="0" y="0"/>
+          <a:chExt cx="0" cy="0"/>
+        </a:xfrm>
+      </p:grpSpPr>
       <p:pic>
         <p:nvPicPr>
           <p:cNvPr id="2" name="Picture 1" descr="image2.png"/>
@@ -6655,7 +7004,7 @@
           <p:nvPr/>
         </p:nvPicPr>
         <p:blipFill>
-          <a:blip r:embed="rId2"/>
+          <a:blip r:embed="rId3"/>
           <a:stretch>
             <a:fillRect/>
           </a:stretch>
@@ -6687,7 +7036,7 @@
           <a:noFill/>
         </p:spPr>
         <p:txBody>
-          <a:bodyPr wrap="square" lIns="0" rIns="0" tIns="0" bIns="0" anchor="t">
+          <a:bodyPr wrap="square" lIns="0" tIns="0" rIns="0" bIns="0" anchor="t">
             <a:spAutoFit/>
           </a:bodyPr>
           <a:lstStyle/>
@@ -6726,7 +7075,7 @@
           <a:noFill/>
         </p:spPr>
         <p:txBody>
-          <a:bodyPr wrap="square" lIns="0" rIns="0" tIns="0" bIns="0" anchor="ctr">
+          <a:bodyPr wrap="square" lIns="0" tIns="0" rIns="0" bIns="0" anchor="ctr">
             <a:spAutoFit/>
           </a:bodyPr>
           <a:lstStyle/>
@@ -6765,7 +7114,7 @@
           <a:noFill/>
         </p:spPr>
         <p:txBody>
-          <a:bodyPr wrap="square" lIns="0" rIns="0" tIns="0" bIns="0" anchor="t">
+          <a:bodyPr wrap="square" lIns="0" tIns="0" rIns="0" bIns="0" anchor="t">
             <a:spAutoFit/>
           </a:bodyPr>
           <a:lstStyle/>
@@ -6795,7 +7144,7 @@
         </p:nvSpPr>
         <p:spPr>
           <a:xfrm>
-            <a:off x="2926080" y="4754880"/>
+            <a:off x="1835510" y="4754880"/>
             <a:ext cx="3840480" cy="1463040"/>
           </a:xfrm>
           <a:prstGeom prst="rect">
@@ -6804,7 +7153,7 @@
           <a:noFill/>
         </p:spPr>
         <p:txBody>
-          <a:bodyPr wrap="square" lIns="0" rIns="0" tIns="0" bIns="0" anchor="t">
+          <a:bodyPr wrap="square" lIns="0" tIns="0" rIns="0" bIns="0" anchor="t">
             <a:spAutoFit/>
           </a:bodyPr>
           <a:lstStyle/>
@@ -6815,7 +7164,7 @@
               </a:spcAft>
             </a:pPr>
             <a:r>
-              <a:rPr sz="2200" b="0">
+              <a:rPr sz="2200" b="0" dirty="0">
                 <a:solidFill>
                   <a:srgbClr val="000000"/>
                 </a:solidFill>
@@ -6831,13 +7180,22 @@
               </a:spcAft>
             </a:pPr>
             <a:r>
-              <a:rPr sz="2200" b="0">
+              <a:rPr sz="2200" b="0" dirty="0" err="1">
                 <a:solidFill>
                   <a:srgbClr val="000000"/>
                 </a:solidFill>
                 <a:latin typeface="Times New Roman"/>
               </a:rPr>
-              <a:t>Dhairya Shah</a:t>
+              <a:t>Dhairya</a:t>
+            </a:r>
+            <a:r>
+              <a:rPr sz="2200" b="0" dirty="0">
+                <a:solidFill>
+                  <a:srgbClr val="000000"/>
+                </a:solidFill>
+                <a:latin typeface="Times New Roman"/>
+              </a:rPr>
+              <a:t> Shah</a:t>
             </a:r>
           </a:p>
           <a:p>
@@ -6847,14 +7205,29 @@
               </a:spcAft>
             </a:pPr>
             <a:r>
-              <a:rPr sz="2200" b="0">
+              <a:rPr sz="2200" b="0" dirty="0">
                 <a:solidFill>
                   <a:srgbClr val="000000"/>
                 </a:solidFill>
                 <a:latin typeface="Times New Roman"/>
               </a:rPr>
-              <a:t>Jay Daftari</a:t>
-            </a:r>
+              <a:t>Jay </a:t>
+            </a:r>
+            <a:r>
+              <a:rPr sz="2200" b="0" dirty="0" err="1">
+                <a:solidFill>
+                  <a:srgbClr val="000000"/>
+                </a:solidFill>
+                <a:latin typeface="Times New Roman"/>
+              </a:rPr>
+              <a:t>Daftari</a:t>
+            </a:r>
+            <a:endParaRPr sz="2200" b="0" dirty="0">
+              <a:solidFill>
+                <a:srgbClr val="000000"/>
+              </a:solidFill>
+              <a:latin typeface="Times New Roman"/>
+            </a:endParaRPr>
           </a:p>
           <a:p>
             <a:pPr algn="r">
@@ -6863,14 +7236,29 @@
               </a:spcAft>
             </a:pPr>
             <a:r>
-              <a:rPr sz="2200" b="0">
+              <a:rPr sz="2200" b="0" dirty="0">
                 <a:solidFill>
                   <a:srgbClr val="000000"/>
                 </a:solidFill>
                 <a:latin typeface="Times New Roman"/>
               </a:rPr>
-              <a:t>Hiya Soni</a:t>
-            </a:r>
+              <a:t>Hiya </a:t>
+            </a:r>
+            <a:r>
+              <a:rPr sz="2200" b="0" dirty="0" err="1">
+                <a:solidFill>
+                  <a:srgbClr val="000000"/>
+                </a:solidFill>
+                <a:latin typeface="Times New Roman"/>
+              </a:rPr>
+              <a:t>Soni</a:t>
+            </a:r>
+            <a:endParaRPr sz="2200" b="0" dirty="0">
+              <a:solidFill>
+                <a:srgbClr val="000000"/>
+              </a:solidFill>
+              <a:latin typeface="Times New Roman"/>
+            </a:endParaRPr>
           </a:p>
         </p:txBody>
       </p:sp>
@@ -6882,7 +7270,7 @@
         </p:nvSpPr>
         <p:spPr>
           <a:xfrm>
-            <a:off x="6949440" y="4754880"/>
+            <a:off x="5858870" y="4754880"/>
             <a:ext cx="2743200" cy="1463040"/>
           </a:xfrm>
           <a:prstGeom prst="rect">
@@ -6891,7 +7279,7 @@
           <a:noFill/>
         </p:spPr>
         <p:txBody>
-          <a:bodyPr wrap="square" lIns="0" rIns="0" tIns="0" bIns="0" anchor="t">
+          <a:bodyPr wrap="square" lIns="0" tIns="0" rIns="0" bIns="0" anchor="t">
             <a:spAutoFit/>
           </a:bodyPr>
           <a:lstStyle/>
@@ -6902,7 +7290,7 @@
               </a:spcAft>
             </a:pPr>
             <a:r>
-              <a:rPr sz="2200" b="0">
+              <a:rPr sz="2200" b="0" dirty="0">
                 <a:solidFill>
                   <a:srgbClr val="000000"/>
                 </a:solidFill>
@@ -6918,7 +7306,7 @@
               </a:spcAft>
             </a:pPr>
             <a:r>
-              <a:rPr sz="2200" b="0">
+              <a:rPr sz="2200" b="0" dirty="0">
                 <a:solidFill>
                   <a:srgbClr val="000000"/>
                 </a:solidFill>
@@ -6934,7 +7322,7 @@
               </a:spcAft>
             </a:pPr>
             <a:r>
-              <a:rPr sz="2200" b="0">
+              <a:rPr sz="2200" b="0" dirty="0">
                 <a:solidFill>
                   <a:srgbClr val="000000"/>
                 </a:solidFill>
@@ -6950,7 +7338,7 @@
               </a:spcAft>
             </a:pPr>
             <a:r>
-              <a:rPr sz="2200" b="0">
+              <a:rPr sz="2200" b="0" dirty="0">
                 <a:solidFill>
                   <a:srgbClr val="000000"/>
                 </a:solidFill>
@@ -6978,7 +7366,7 @@
           <a:noFill/>
         </p:spPr>
         <p:txBody>
-          <a:bodyPr wrap="square" lIns="0" rIns="0" tIns="0" bIns="0" anchor="t">
+          <a:bodyPr wrap="square" lIns="0" tIns="0" rIns="0" bIns="0" anchor="t">
             <a:spAutoFit/>
           </a:bodyPr>
           <a:lstStyle/>
@@ -7065,7 +7453,7 @@
           <a:noFill/>
         </p:spPr>
         <p:txBody>
-          <a:bodyPr wrap="square" lIns="0" rIns="0" tIns="0" bIns="0" anchor="t">
+          <a:bodyPr wrap="square" lIns="0" tIns="0" rIns="0" bIns="0" anchor="t">
             <a:spAutoFit/>
           </a:bodyPr>
           <a:lstStyle/>
@@ -7096,7 +7484,7 @@
 </file>
 
 <file path=ppt/slides/slide10.xml><?xml version="1.0" encoding="utf-8"?>
-<p:sld xmlns:a="http://schemas.openxmlformats.org/drawingml/2006/main" xmlns:p="http://schemas.openxmlformats.org/presentationml/2006/main" xmlns:r="http://schemas.openxmlformats.org/officeDocument/2006/relationships">
+<p:sld xmlns:a="http://schemas.openxmlformats.org/drawingml/2006/main" xmlns:r="http://schemas.openxmlformats.org/officeDocument/2006/relationships" xmlns:p="http://schemas.openxmlformats.org/presentationml/2006/main">
   <p:cSld>
     <p:bg>
       <p:bgPr>
@@ -7112,7 +7500,14 @@
         <p:cNvGrpSpPr/>
         <p:nvPr/>
       </p:nvGrpSpPr>
-      <p:grpSpPr/>
+      <p:grpSpPr>
+        <a:xfrm>
+          <a:off x="0" y="0"/>
+          <a:ext cx="0" cy="0"/>
+          <a:chOff x="0" y="0"/>
+          <a:chExt cx="0" cy="0"/>
+        </a:xfrm>
+      </p:grpSpPr>
       <p:sp>
         <p:nvSpPr>
           <p:cNvPr id="2" name="Title"/>
@@ -7130,7 +7525,7 @@
           <a:noFill/>
         </p:spPr>
         <p:txBody>
-          <a:bodyPr wrap="square" lIns="0" rIns="0" tIns="0" bIns="0" anchor="ctr">
+          <a:bodyPr wrap="square" lIns="0" tIns="0" rIns="0" bIns="0" anchor="ctr">
             <a:spAutoFit/>
           </a:bodyPr>
           <a:lstStyle/>
@@ -7169,7 +7564,7 @@
           <a:noFill/>
         </p:spPr>
         <p:txBody>
-          <a:bodyPr wrap="square" lIns="0" rIns="0" tIns="0" bIns="0" anchor="ctr">
+          <a:bodyPr wrap="square" lIns="0" tIns="0" rIns="0" bIns="0" anchor="ctr">
             <a:spAutoFit/>
           </a:bodyPr>
           <a:lstStyle/>
@@ -7236,6 +7631,7 @@
           <a:lstStyle/>
           <a:p>
             <a:pPr algn="ctr"/>
+            <a:endParaRPr/>
           </a:p>
         </p:txBody>
       </p:sp>
@@ -7256,7 +7652,7 @@
           <a:noFill/>
         </p:spPr>
         <p:txBody>
-          <a:bodyPr wrap="square" lIns="0" rIns="0" tIns="0" bIns="0" anchor="ctr">
+          <a:bodyPr wrap="square" lIns="0" tIns="0" rIns="0" bIns="0" anchor="ctr">
             <a:spAutoFit/>
           </a:bodyPr>
           <a:lstStyle/>
@@ -7295,7 +7691,7 @@
           <a:noFill/>
         </p:spPr>
         <p:txBody>
-          <a:bodyPr wrap="square" lIns="0" rIns="0" tIns="0" bIns="0" anchor="t">
+          <a:bodyPr wrap="square" lIns="0" tIns="0" rIns="0" bIns="0" anchor="t">
             <a:spAutoFit/>
           </a:bodyPr>
           <a:lstStyle/>
@@ -7334,12 +7730,12 @@
           <a:noFill/>
         </p:spPr>
         <p:txBody>
-          <a:bodyPr wrap="square" lIns="0" rIns="0" tIns="0" bIns="0" anchor="t">
+          <a:bodyPr wrap="square" lIns="0" tIns="0" rIns="0" bIns="0" anchor="t">
             <a:spAutoFit/>
           </a:bodyPr>
           <a:lstStyle/>
           <a:p>
-            <a:pPr algn="l" marL="285750" indent="-285750">
+            <a:pPr marL="285750" indent="-285750" algn="l">
               <a:spcAft>
                 <a:spcPts val="1400"/>
               </a:spcAft>
@@ -7357,7 +7753,7 @@
             </a:r>
           </a:p>
           <a:p>
-            <a:pPr algn="l" marL="285750" indent="-285750">
+            <a:pPr marL="285750" indent="-285750" algn="l">
               <a:spcAft>
                 <a:spcPts val="1400"/>
               </a:spcAft>
@@ -7375,7 +7771,7 @@
             </a:r>
           </a:p>
           <a:p>
-            <a:pPr algn="l" marL="285750" indent="-285750">
+            <a:pPr marL="285750" indent="-285750" algn="l">
               <a:spcAft>
                 <a:spcPts val="1400"/>
               </a:spcAft>
@@ -7439,6 +7835,7 @@
           <a:lstStyle/>
           <a:p>
             <a:pPr algn="ctr"/>
+            <a:endParaRPr/>
           </a:p>
         </p:txBody>
       </p:sp>
@@ -7459,7 +7856,7 @@
           <a:noFill/>
         </p:spPr>
         <p:txBody>
-          <a:bodyPr wrap="square" lIns="0" rIns="0" tIns="0" bIns="0" anchor="ctr">
+          <a:bodyPr wrap="square" lIns="0" tIns="0" rIns="0" bIns="0" anchor="ctr">
             <a:spAutoFit/>
           </a:bodyPr>
           <a:lstStyle/>
@@ -7498,7 +7895,7 @@
           <a:noFill/>
         </p:spPr>
         <p:txBody>
-          <a:bodyPr wrap="square" lIns="0" rIns="0" tIns="0" bIns="0" anchor="t">
+          <a:bodyPr wrap="square" lIns="0" tIns="0" rIns="0" bIns="0" anchor="t">
             <a:spAutoFit/>
           </a:bodyPr>
           <a:lstStyle/>
@@ -7537,12 +7934,12 @@
           <a:noFill/>
         </p:spPr>
         <p:txBody>
-          <a:bodyPr wrap="square" lIns="0" rIns="0" tIns="0" bIns="0" anchor="t">
+          <a:bodyPr wrap="square" lIns="0" tIns="0" rIns="0" bIns="0" anchor="t">
             <a:spAutoFit/>
           </a:bodyPr>
           <a:lstStyle/>
           <a:p>
-            <a:pPr algn="l" marL="285750" indent="-285750">
+            <a:pPr marL="285750" indent="-285750" algn="l">
               <a:spcAft>
                 <a:spcPts val="1400"/>
               </a:spcAft>
@@ -7560,7 +7957,7 @@
             </a:r>
           </a:p>
           <a:p>
-            <a:pPr algn="l" marL="285750" indent="-285750">
+            <a:pPr marL="285750" indent="-285750" algn="l">
               <a:spcAft>
                 <a:spcPts val="1400"/>
               </a:spcAft>
@@ -7578,7 +7975,7 @@
             </a:r>
           </a:p>
           <a:p>
-            <a:pPr algn="l" marL="285750" indent="-285750">
+            <a:pPr marL="285750" indent="-285750" algn="l">
               <a:spcAft>
                 <a:spcPts val="1400"/>
               </a:spcAft>
@@ -7642,6 +8039,7 @@
           <a:lstStyle/>
           <a:p>
             <a:pPr algn="ctr"/>
+            <a:endParaRPr/>
           </a:p>
         </p:txBody>
       </p:sp>
@@ -7662,7 +8060,7 @@
           <a:noFill/>
         </p:spPr>
         <p:txBody>
-          <a:bodyPr wrap="square" lIns="0" rIns="0" tIns="0" bIns="0" anchor="ctr">
+          <a:bodyPr wrap="square" lIns="0" tIns="0" rIns="0" bIns="0" anchor="ctr">
             <a:spAutoFit/>
           </a:bodyPr>
           <a:lstStyle/>
@@ -7701,7 +8099,7 @@
           <a:noFill/>
         </p:spPr>
         <p:txBody>
-          <a:bodyPr wrap="square" lIns="0" rIns="0" tIns="0" bIns="0" anchor="t">
+          <a:bodyPr wrap="square" lIns="0" tIns="0" rIns="0" bIns="0" anchor="t">
             <a:spAutoFit/>
           </a:bodyPr>
           <a:lstStyle/>
@@ -7740,12 +8138,12 @@
           <a:noFill/>
         </p:spPr>
         <p:txBody>
-          <a:bodyPr wrap="square" lIns="0" rIns="0" tIns="0" bIns="0" anchor="t">
+          <a:bodyPr wrap="square" lIns="0" tIns="0" rIns="0" bIns="0" anchor="t">
             <a:spAutoFit/>
           </a:bodyPr>
           <a:lstStyle/>
           <a:p>
-            <a:pPr algn="l" marL="285750" indent="-285750">
+            <a:pPr marL="285750" indent="-285750" algn="l">
               <a:spcAft>
                 <a:spcPts val="1400"/>
               </a:spcAft>
@@ -7763,7 +8161,7 @@
             </a:r>
           </a:p>
           <a:p>
-            <a:pPr algn="l" marL="285750" indent="-285750">
+            <a:pPr marL="285750" indent="-285750" algn="l">
               <a:spcAft>
                 <a:spcPts val="1400"/>
               </a:spcAft>
@@ -7781,7 +8179,7 @@
             </a:r>
           </a:p>
           <a:p>
-            <a:pPr algn="l" marL="285750" indent="-285750">
+            <a:pPr marL="285750" indent="-285750" algn="l">
               <a:spcAft>
                 <a:spcPts val="1400"/>
               </a:spcAft>
@@ -7845,6 +8243,7 @@
           <a:lstStyle/>
           <a:p>
             <a:pPr algn="ctr"/>
+            <a:endParaRPr/>
           </a:p>
         </p:txBody>
       </p:sp>
@@ -7865,7 +8264,7 @@
           <a:noFill/>
         </p:spPr>
         <p:txBody>
-          <a:bodyPr wrap="square" lIns="0" rIns="0" tIns="0" bIns="0" anchor="ctr">
+          <a:bodyPr wrap="square" lIns="0" tIns="0" rIns="0" bIns="0" anchor="ctr">
             <a:spAutoFit/>
           </a:bodyPr>
           <a:lstStyle/>
@@ -7904,7 +8303,7 @@
           <a:noFill/>
         </p:spPr>
         <p:txBody>
-          <a:bodyPr wrap="square" lIns="0" rIns="0" tIns="0" bIns="0" anchor="t">
+          <a:bodyPr wrap="square" lIns="0" tIns="0" rIns="0" bIns="0" anchor="t">
             <a:spAutoFit/>
           </a:bodyPr>
           <a:lstStyle/>
@@ -7943,12 +8342,12 @@
           <a:noFill/>
         </p:spPr>
         <p:txBody>
-          <a:bodyPr wrap="square" lIns="0" rIns="0" tIns="0" bIns="0" anchor="t">
+          <a:bodyPr wrap="square" lIns="0" tIns="0" rIns="0" bIns="0" anchor="t">
             <a:spAutoFit/>
           </a:bodyPr>
           <a:lstStyle/>
           <a:p>
-            <a:pPr algn="l" marL="285750" indent="-285750">
+            <a:pPr marL="285750" indent="-285750" algn="l">
               <a:spcAft>
                 <a:spcPts val="1400"/>
               </a:spcAft>
@@ -7966,7 +8365,7 @@
             </a:r>
           </a:p>
           <a:p>
-            <a:pPr algn="l" marL="285750" indent="-285750">
+            <a:pPr marL="285750" indent="-285750" algn="l">
               <a:spcAft>
                 <a:spcPts val="1400"/>
               </a:spcAft>
@@ -7984,7 +8383,7 @@
             </a:r>
           </a:p>
           <a:p>
-            <a:pPr algn="l" marL="285750" indent="-285750">
+            <a:pPr marL="285750" indent="-285750" algn="l">
               <a:spcAft>
                 <a:spcPts val="1400"/>
               </a:spcAft>
@@ -8012,7 +8411,7 @@
 </file>
 
 <file path=ppt/slides/slide2.xml><?xml version="1.0" encoding="utf-8"?>
-<p:sld xmlns:a="http://schemas.openxmlformats.org/drawingml/2006/main" xmlns:p="http://schemas.openxmlformats.org/presentationml/2006/main" xmlns:r="http://schemas.openxmlformats.org/officeDocument/2006/relationships">
+<p:sld xmlns:a="http://schemas.openxmlformats.org/drawingml/2006/main" xmlns:r="http://schemas.openxmlformats.org/officeDocument/2006/relationships" xmlns:p="http://schemas.openxmlformats.org/presentationml/2006/main">
   <p:cSld>
     <p:bg>
       <p:bgPr>
@@ -8028,7 +8427,14 @@
         <p:cNvGrpSpPr/>
         <p:nvPr/>
       </p:nvGrpSpPr>
-      <p:grpSpPr/>
+      <p:grpSpPr>
+        <a:xfrm>
+          <a:off x="0" y="0"/>
+          <a:ext cx="0" cy="0"/>
+          <a:chOff x="0" y="0"/>
+          <a:chExt cx="0" cy="0"/>
+        </a:xfrm>
+      </p:grpSpPr>
       <p:sp>
         <p:nvSpPr>
           <p:cNvPr id="2" name="Title"/>
@@ -8046,7 +8452,7 @@
           <a:noFill/>
         </p:spPr>
         <p:txBody>
-          <a:bodyPr wrap="square" lIns="0" rIns="0" tIns="0" bIns="0" anchor="ctr">
+          <a:bodyPr wrap="square" lIns="0" tIns="0" rIns="0" bIns="0" anchor="ctr">
             <a:spAutoFit/>
           </a:bodyPr>
           <a:lstStyle/>
@@ -8085,7 +8491,7 @@
           <a:noFill/>
         </p:spPr>
         <p:txBody>
-          <a:bodyPr wrap="square" lIns="0" rIns="0" tIns="0" bIns="0" anchor="ctr">
+          <a:bodyPr wrap="square" lIns="0" tIns="0" rIns="0" bIns="0" anchor="ctr">
             <a:spAutoFit/>
           </a:bodyPr>
           <a:lstStyle/>
@@ -8121,7 +8527,7 @@
         </p:xfrm>
         <a:graphic>
           <a:graphicData uri="http://schemas.openxmlformats.org/drawingml/2006/chart">
-            <c:chart xmlns:c="http://schemas.openxmlformats.org/drawingml/2006/chart" r:id="rId2"/>
+            <c:chart xmlns:c="http://schemas.openxmlformats.org/drawingml/2006/chart" xmlns:r="http://schemas.openxmlformats.org/officeDocument/2006/relationships" r:id="rId3"/>
           </a:graphicData>
         </a:graphic>
       </p:graphicFrame>
@@ -8142,7 +8548,7 @@
           <a:noFill/>
         </p:spPr>
         <p:txBody>
-          <a:bodyPr wrap="square" lIns="0" rIns="0" tIns="0" bIns="0" anchor="t">
+          <a:bodyPr wrap="square" lIns="0" tIns="0" rIns="0" bIns="0" anchor="t">
             <a:spAutoFit/>
           </a:bodyPr>
           <a:lstStyle/>
@@ -8209,6 +8615,7 @@
           <a:lstStyle/>
           <a:p>
             <a:pPr algn="ctr"/>
+            <a:endParaRPr/>
           </a:p>
         </p:txBody>
       </p:sp>
@@ -8229,7 +8636,7 @@
           <a:noFill/>
         </p:spPr>
         <p:txBody>
-          <a:bodyPr wrap="square" lIns="0" rIns="0" tIns="0" bIns="0" anchor="ctr">
+          <a:bodyPr wrap="square" lIns="0" tIns="0" rIns="0" bIns="0" anchor="ctr">
             <a:spAutoFit/>
           </a:bodyPr>
           <a:lstStyle/>
@@ -8268,12 +8675,12 @@
           <a:noFill/>
         </p:spPr>
         <p:txBody>
-          <a:bodyPr wrap="square" lIns="0" rIns="0" tIns="0" bIns="0" anchor="t">
+          <a:bodyPr wrap="square" lIns="0" tIns="0" rIns="0" bIns="0" anchor="t">
             <a:spAutoFit/>
           </a:bodyPr>
           <a:lstStyle/>
           <a:p>
-            <a:pPr algn="l" marL="285750" indent="-285750">
+            <a:pPr marL="285750" indent="-285750" algn="l">
               <a:spcAft>
                 <a:spcPts val="800"/>
               </a:spcAft>
@@ -8291,7 +8698,7 @@
             </a:r>
           </a:p>
           <a:p>
-            <a:pPr algn="l" marL="285750" indent="-285750">
+            <a:pPr marL="285750" indent="-285750" algn="l">
               <a:spcAft>
                 <a:spcPts val="800"/>
               </a:spcAft>
@@ -8355,6 +8762,7 @@
           <a:lstStyle/>
           <a:p>
             <a:pPr algn="ctr"/>
+            <a:endParaRPr/>
           </a:p>
         </p:txBody>
       </p:sp>
@@ -8375,7 +8783,7 @@
           <a:noFill/>
         </p:spPr>
         <p:txBody>
-          <a:bodyPr wrap="square" lIns="0" rIns="0" tIns="0" bIns="0" anchor="ctr">
+          <a:bodyPr wrap="square" lIns="0" tIns="0" rIns="0" bIns="0" anchor="ctr">
             <a:spAutoFit/>
           </a:bodyPr>
           <a:lstStyle/>
@@ -8414,12 +8822,12 @@
           <a:noFill/>
         </p:spPr>
         <p:txBody>
-          <a:bodyPr wrap="square" lIns="0" rIns="0" tIns="0" bIns="0" anchor="t">
+          <a:bodyPr wrap="square" lIns="0" tIns="0" rIns="0" bIns="0" anchor="t">
             <a:spAutoFit/>
           </a:bodyPr>
           <a:lstStyle/>
           <a:p>
-            <a:pPr algn="l" marL="285750" indent="-285750">
+            <a:pPr marL="285750" indent="-285750" algn="l">
               <a:spcAft>
                 <a:spcPts val="800"/>
               </a:spcAft>
@@ -8437,7 +8845,7 @@
             </a:r>
           </a:p>
           <a:p>
-            <a:pPr algn="l" marL="285750" indent="-285750">
+            <a:pPr marL="285750" indent="-285750" algn="l">
               <a:spcAft>
                 <a:spcPts val="800"/>
               </a:spcAft>
@@ -8501,6 +8909,7 @@
           <a:lstStyle/>
           <a:p>
             <a:pPr algn="ctr"/>
+            <a:endParaRPr/>
           </a:p>
         </p:txBody>
       </p:sp>
@@ -8521,7 +8930,7 @@
           <a:noFill/>
         </p:spPr>
         <p:txBody>
-          <a:bodyPr wrap="square" lIns="0" rIns="0" tIns="0" bIns="0" anchor="ctr">
+          <a:bodyPr wrap="square" lIns="0" tIns="0" rIns="0" bIns="0" anchor="ctr">
             <a:spAutoFit/>
           </a:bodyPr>
           <a:lstStyle/>
@@ -8561,7 +8970,7 @@
 </file>
 
 <file path=ppt/slides/slide3.xml><?xml version="1.0" encoding="utf-8"?>
-<p:sld xmlns:a="http://schemas.openxmlformats.org/drawingml/2006/main" xmlns:p="http://schemas.openxmlformats.org/presentationml/2006/main" xmlns:r="http://schemas.openxmlformats.org/officeDocument/2006/relationships">
+<p:sld xmlns:a="http://schemas.openxmlformats.org/drawingml/2006/main" xmlns:r="http://schemas.openxmlformats.org/officeDocument/2006/relationships" xmlns:p="http://schemas.openxmlformats.org/presentationml/2006/main">
   <p:cSld>
     <p:bg>
       <p:bgPr>
@@ -8577,7 +8986,14 @@
         <p:cNvGrpSpPr/>
         <p:nvPr/>
       </p:nvGrpSpPr>
-      <p:grpSpPr/>
+      <p:grpSpPr>
+        <a:xfrm>
+          <a:off x="0" y="0"/>
+          <a:ext cx="0" cy="0"/>
+          <a:chOff x="0" y="0"/>
+          <a:chExt cx="0" cy="0"/>
+        </a:xfrm>
+      </p:grpSpPr>
       <p:sp>
         <p:nvSpPr>
           <p:cNvPr id="2" name="Title"/>
@@ -8595,7 +9011,7 @@
           <a:noFill/>
         </p:spPr>
         <p:txBody>
-          <a:bodyPr wrap="square" lIns="0" rIns="0" tIns="0" bIns="0" anchor="ctr">
+          <a:bodyPr wrap="square" lIns="0" tIns="0" rIns="0" bIns="0" anchor="ctr">
             <a:spAutoFit/>
           </a:bodyPr>
           <a:lstStyle/>
@@ -8634,7 +9050,7 @@
           <a:noFill/>
         </p:spPr>
         <p:txBody>
-          <a:bodyPr wrap="square" lIns="0" rIns="0" tIns="0" bIns="0" anchor="ctr">
+          <a:bodyPr wrap="square" lIns="0" tIns="0" rIns="0" bIns="0" anchor="ctr">
             <a:spAutoFit/>
           </a:bodyPr>
           <a:lstStyle/>
@@ -8701,6 +9117,7 @@
           <a:lstStyle/>
           <a:p>
             <a:pPr algn="ctr"/>
+            <a:endParaRPr/>
           </a:p>
         </p:txBody>
       </p:sp>
@@ -8721,7 +9138,7 @@
           <a:noFill/>
         </p:spPr>
         <p:txBody>
-          <a:bodyPr wrap="square" lIns="0" rIns="0" tIns="0" bIns="0" anchor="ctr">
+          <a:bodyPr wrap="square" lIns="0" tIns="0" rIns="0" bIns="0" anchor="ctr">
             <a:spAutoFit/>
           </a:bodyPr>
           <a:lstStyle/>
@@ -8840,6 +9257,7 @@
           <a:lstStyle/>
           <a:p>
             <a:pPr algn="ctr"/>
+            <a:endParaRPr/>
           </a:p>
         </p:txBody>
       </p:sp>
@@ -8860,7 +9278,7 @@
           <a:noFill/>
         </p:spPr>
         <p:txBody>
-          <a:bodyPr wrap="square" lIns="0" rIns="0" tIns="0" bIns="0" anchor="ctr">
+          <a:bodyPr wrap="square" lIns="0" tIns="0" rIns="0" bIns="0" anchor="ctr">
             <a:spAutoFit/>
           </a:bodyPr>
           <a:lstStyle/>
@@ -8899,12 +9317,12 @@
           <a:noFill/>
         </p:spPr>
         <p:txBody>
-          <a:bodyPr wrap="square" lIns="0" rIns="0" tIns="0" bIns="0" anchor="t">
+          <a:bodyPr wrap="square" lIns="0" tIns="0" rIns="0" bIns="0" anchor="t">
             <a:spAutoFit/>
           </a:bodyPr>
           <a:lstStyle/>
           <a:p>
-            <a:pPr algn="l" marL="285750" indent="-285750">
+            <a:pPr marL="285750" indent="-285750" algn="l">
               <a:spcAft>
                 <a:spcPts val="800"/>
               </a:spcAft>
@@ -8922,7 +9340,7 @@
             </a:r>
           </a:p>
           <a:p>
-            <a:pPr algn="l" marL="285750" indent="-285750">
+            <a:pPr marL="285750" indent="-285750" algn="l">
               <a:spcAft>
                 <a:spcPts val="800"/>
               </a:spcAft>
@@ -8940,7 +9358,7 @@
             </a:r>
           </a:p>
           <a:p>
-            <a:pPr algn="l" marL="285750" indent="-285750">
+            <a:pPr marL="285750" indent="-285750" algn="l">
               <a:spcAft>
                 <a:spcPts val="800"/>
               </a:spcAft>
@@ -9004,6 +9422,7 @@
           <a:lstStyle/>
           <a:p>
             <a:pPr algn="ctr"/>
+            <a:endParaRPr/>
           </a:p>
         </p:txBody>
       </p:sp>
@@ -9024,7 +9443,7 @@
           <a:noFill/>
         </p:spPr>
         <p:txBody>
-          <a:bodyPr wrap="square" lIns="0" rIns="0" tIns="0" bIns="0" anchor="ctr">
+          <a:bodyPr wrap="square" lIns="0" tIns="0" rIns="0" bIns="0" anchor="ctr">
             <a:spAutoFit/>
           </a:bodyPr>
           <a:lstStyle/>
@@ -9063,12 +9482,12 @@
           <a:noFill/>
         </p:spPr>
         <p:txBody>
-          <a:bodyPr wrap="square" lIns="0" rIns="0" tIns="0" bIns="0" anchor="t">
+          <a:bodyPr wrap="square" lIns="0" tIns="0" rIns="0" bIns="0" anchor="t">
             <a:spAutoFit/>
           </a:bodyPr>
           <a:lstStyle/>
           <a:p>
-            <a:pPr algn="l" marL="285750" indent="-285750">
+            <a:pPr marL="285750" indent="-285750" algn="l">
               <a:spcAft>
                 <a:spcPts val="800"/>
               </a:spcAft>
@@ -9076,7 +9495,7 @@
               <a:buChar char="•"/>
             </a:pPr>
             <a:r>
-              <a:rPr sz="2200" b="0">
+              <a:rPr sz="2200" b="0" dirty="0">
                 <a:solidFill>
                   <a:srgbClr val="000000"/>
                 </a:solidFill>
@@ -9086,7 +9505,7 @@
             </a:r>
           </a:p>
           <a:p>
-            <a:pPr algn="l" marL="285750" indent="-285750">
+            <a:pPr marL="285750" indent="-285750" algn="l">
               <a:spcAft>
                 <a:spcPts val="800"/>
               </a:spcAft>
@@ -9094,7 +9513,7 @@
               <a:buChar char="•"/>
             </a:pPr>
             <a:r>
-              <a:rPr sz="2200" b="0">
+              <a:rPr sz="2200" b="0" dirty="0">
                 <a:solidFill>
                   <a:srgbClr val="000000"/>
                 </a:solidFill>
@@ -9104,7 +9523,7 @@
             </a:r>
           </a:p>
           <a:p>
-            <a:pPr algn="l" marL="285750" indent="-285750">
+            <a:pPr marL="285750" indent="-285750" algn="l">
               <a:spcAft>
                 <a:spcPts val="800"/>
               </a:spcAft>
@@ -9112,7 +9531,7 @@
               <a:buChar char="•"/>
             </a:pPr>
             <a:r>
-              <a:rPr sz="2200" b="0">
+              <a:rPr sz="2200" b="0" dirty="0">
                 <a:solidFill>
                   <a:srgbClr val="000000"/>
                 </a:solidFill>
@@ -9132,7 +9551,7 @@
 </file>
 
 <file path=ppt/slides/slide4.xml><?xml version="1.0" encoding="utf-8"?>
-<p:sld xmlns:a="http://schemas.openxmlformats.org/drawingml/2006/main" xmlns:p="http://schemas.openxmlformats.org/presentationml/2006/main" xmlns:r="http://schemas.openxmlformats.org/officeDocument/2006/relationships">
+<p:sld xmlns:a="http://schemas.openxmlformats.org/drawingml/2006/main" xmlns:r="http://schemas.openxmlformats.org/officeDocument/2006/relationships" xmlns:p="http://schemas.openxmlformats.org/presentationml/2006/main">
   <p:cSld>
     <p:bg>
       <p:bgPr>
@@ -9148,7 +9567,14 @@
         <p:cNvGrpSpPr/>
         <p:nvPr/>
       </p:nvGrpSpPr>
-      <p:grpSpPr/>
+      <p:grpSpPr>
+        <a:xfrm>
+          <a:off x="0" y="0"/>
+          <a:ext cx="0" cy="0"/>
+          <a:chOff x="0" y="0"/>
+          <a:chExt cx="0" cy="0"/>
+        </a:xfrm>
+      </p:grpSpPr>
       <p:sp>
         <p:nvSpPr>
           <p:cNvPr id="2" name="Title"/>
@@ -9166,7 +9592,7 @@
           <a:noFill/>
         </p:spPr>
         <p:txBody>
-          <a:bodyPr wrap="square" lIns="0" rIns="0" tIns="0" bIns="0" anchor="ctr">
+          <a:bodyPr wrap="square" lIns="0" tIns="0" rIns="0" bIns="0" anchor="ctr">
             <a:spAutoFit/>
           </a:bodyPr>
           <a:lstStyle/>
@@ -9205,7 +9631,7 @@
           <a:noFill/>
         </p:spPr>
         <p:txBody>
-          <a:bodyPr wrap="square" lIns="0" rIns="0" tIns="0" bIns="0" anchor="ctr">
+          <a:bodyPr wrap="square" lIns="0" tIns="0" rIns="0" bIns="0" anchor="ctr">
             <a:spAutoFit/>
           </a:bodyPr>
           <a:lstStyle/>
@@ -9237,7 +9663,7 @@
         </p:nvGraphicFramePr>
         <p:xfrm>
           <a:off x="502920" y="1645920"/>
-          <a:ext cx="11183112" cy="3200400"/>
+          <a:ext cx="11183112" cy="3285744"/>
         </p:xfrm>
         <a:graphic>
           <a:graphicData uri="http://schemas.openxmlformats.org/drawingml/2006/table">
@@ -9246,15 +9672,39 @@
                 <a:tableStyleId>{5940675A-B579-460E-94D1-54222C63F5DA}</a:tableStyleId>
               </a:tblPr>
               <a:tblGrid>
-                <a:gridCol w="731520"/>
-                <a:gridCol w="3383280"/>
-                <a:gridCol w="3840480"/>
-                <a:gridCol w="3227832"/>
+                <a:gridCol w="731520">
+                  <a:extLst>
+                    <a:ext uri="{9D8B030D-6E8A-4147-A177-3AD203B41FA5}">
+                      <a16:colId xmlns:a16="http://schemas.microsoft.com/office/drawing/2014/main" val="20000"/>
+                    </a:ext>
+                  </a:extLst>
+                </a:gridCol>
+                <a:gridCol w="3383280">
+                  <a:extLst>
+                    <a:ext uri="{9D8B030D-6E8A-4147-A177-3AD203B41FA5}">
+                      <a16:colId xmlns:a16="http://schemas.microsoft.com/office/drawing/2014/main" val="20001"/>
+                    </a:ext>
+                  </a:extLst>
+                </a:gridCol>
+                <a:gridCol w="3840480">
+                  <a:extLst>
+                    <a:ext uri="{9D8B030D-6E8A-4147-A177-3AD203B41FA5}">
+                      <a16:colId xmlns:a16="http://schemas.microsoft.com/office/drawing/2014/main" val="20002"/>
+                    </a:ext>
+                  </a:extLst>
+                </a:gridCol>
+                <a:gridCol w="3227832">
+                  <a:extLst>
+                    <a:ext uri="{9D8B030D-6E8A-4147-A177-3AD203B41FA5}">
+                      <a16:colId xmlns:a16="http://schemas.microsoft.com/office/drawing/2014/main" val="20003"/>
+                    </a:ext>
+                  </a:extLst>
+                </a:gridCol>
               </a:tblGrid>
               <a:tr h="457200">
                 <a:tc>
                   <a:txBody>
-                    <a:bodyPr wrap="square"/>
+                    <a:bodyPr/>
                     <a:lstStyle/>
                     <a:p>
                       <a:pPr algn="ctr"/>
@@ -9269,7 +9719,7 @@
                       </a:r>
                     </a:p>
                   </a:txBody>
-                  <a:tcPr anchor="ctr" marL="73152" marR="73152" marT="27432" marB="27432">
+                  <a:tcPr marL="73152" marR="73152" marT="27432" marB="27432" anchor="ctr">
                     <a:solidFill>
                       <a:srgbClr val="800000"/>
                     </a:solidFill>
@@ -9277,7 +9727,7 @@
                 </a:tc>
                 <a:tc>
                   <a:txBody>
-                    <a:bodyPr wrap="square"/>
+                    <a:bodyPr/>
                     <a:lstStyle/>
                     <a:p>
                       <a:pPr algn="l"/>
@@ -9292,7 +9742,7 @@
                       </a:r>
                     </a:p>
                   </a:txBody>
-                  <a:tcPr anchor="ctr" marL="73152" marR="73152" marT="27432" marB="27432">
+                  <a:tcPr marL="73152" marR="73152" marT="27432" marB="27432" anchor="ctr">
                     <a:solidFill>
                       <a:srgbClr val="800000"/>
                     </a:solidFill>
@@ -9300,7 +9750,7 @@
                 </a:tc>
                 <a:tc>
                   <a:txBody>
-                    <a:bodyPr wrap="square"/>
+                    <a:bodyPr/>
                     <a:lstStyle/>
                     <a:p>
                       <a:pPr algn="l"/>
@@ -9315,7 +9765,7 @@
                       </a:r>
                     </a:p>
                   </a:txBody>
-                  <a:tcPr anchor="ctr" marL="73152" marR="73152" marT="27432" marB="27432">
+                  <a:tcPr marL="73152" marR="73152" marT="27432" marB="27432" anchor="ctr">
                     <a:solidFill>
                       <a:srgbClr val="800000"/>
                     </a:solidFill>
@@ -9323,7 +9773,7 @@
                 </a:tc>
                 <a:tc>
                   <a:txBody>
-                    <a:bodyPr wrap="square"/>
+                    <a:bodyPr/>
                     <a:lstStyle/>
                     <a:p>
                       <a:pPr algn="l"/>
@@ -9338,17 +9788,22 @@
                       </a:r>
                     </a:p>
                   </a:txBody>
-                  <a:tcPr anchor="ctr" marL="73152" marR="73152" marT="27432" marB="27432">
+                  <a:tcPr marL="73152" marR="73152" marT="27432" marB="27432" anchor="ctr">
                     <a:solidFill>
                       <a:srgbClr val="800000"/>
                     </a:solidFill>
                   </a:tcPr>
                 </a:tc>
+                <a:extLst>
+                  <a:ext uri="{0D108BD9-81ED-4DB2-BD59-A6C34878D82A}">
+                    <a16:rowId xmlns:a16="http://schemas.microsoft.com/office/drawing/2014/main" val="10000"/>
+                  </a:ext>
+                </a:extLst>
               </a:tr>
               <a:tr h="457200">
                 <a:tc>
                   <a:txBody>
-                    <a:bodyPr wrap="square"/>
+                    <a:bodyPr/>
                     <a:lstStyle/>
                     <a:p>
                       <a:pPr algn="ctr"/>
@@ -9363,7 +9818,7 @@
                       </a:r>
                     </a:p>
                   </a:txBody>
-                  <a:tcPr anchor="ctr" marL="73152" marR="73152" marT="27432" marB="27432">
+                  <a:tcPr marL="73152" marR="73152" marT="27432" marB="27432" anchor="ctr">
                     <a:solidFill>
                       <a:srgbClr val="FFFFFF"/>
                     </a:solidFill>
@@ -9371,7 +9826,7 @@
                 </a:tc>
                 <a:tc>
                   <a:txBody>
-                    <a:bodyPr wrap="square"/>
+                    <a:bodyPr/>
                     <a:lstStyle/>
                     <a:p>
                       <a:pPr algn="l"/>
@@ -9386,7 +9841,7 @@
                       </a:r>
                     </a:p>
                   </a:txBody>
-                  <a:tcPr anchor="ctr" marL="73152" marR="73152" marT="27432" marB="27432">
+                  <a:tcPr marL="73152" marR="73152" marT="27432" marB="27432" anchor="ctr">
                     <a:solidFill>
                       <a:srgbClr val="FFFFFF"/>
                     </a:solidFill>
@@ -9394,7 +9849,7 @@
                 </a:tc>
                 <a:tc>
                   <a:txBody>
-                    <a:bodyPr wrap="square"/>
+                    <a:bodyPr/>
                     <a:lstStyle/>
                     <a:p>
                       <a:pPr algn="l"/>
@@ -9409,7 +9864,7 @@
                       </a:r>
                     </a:p>
                   </a:txBody>
-                  <a:tcPr anchor="ctr" marL="73152" marR="73152" marT="27432" marB="27432">
+                  <a:tcPr marL="73152" marR="73152" marT="27432" marB="27432" anchor="ctr">
                     <a:solidFill>
                       <a:srgbClr val="FFFFFF"/>
                     </a:solidFill>
@@ -9417,7 +9872,7 @@
                 </a:tc>
                 <a:tc>
                   <a:txBody>
-                    <a:bodyPr wrap="square"/>
+                    <a:bodyPr/>
                     <a:lstStyle/>
                     <a:p>
                       <a:pPr algn="l"/>
@@ -9432,17 +9887,22 @@
                       </a:r>
                     </a:p>
                   </a:txBody>
-                  <a:tcPr anchor="ctr" marL="73152" marR="73152" marT="27432" marB="27432">
+                  <a:tcPr marL="73152" marR="73152" marT="27432" marB="27432" anchor="ctr">
                     <a:solidFill>
                       <a:srgbClr val="FFFFFF"/>
                     </a:solidFill>
                   </a:tcPr>
                 </a:tc>
+                <a:extLst>
+                  <a:ext uri="{0D108BD9-81ED-4DB2-BD59-A6C34878D82A}">
+                    <a16:rowId xmlns:a16="http://schemas.microsoft.com/office/drawing/2014/main" val="10001"/>
+                  </a:ext>
+                </a:extLst>
               </a:tr>
               <a:tr h="457200">
                 <a:tc>
                   <a:txBody>
-                    <a:bodyPr wrap="square"/>
+                    <a:bodyPr/>
                     <a:lstStyle/>
                     <a:p>
                       <a:pPr algn="ctr"/>
@@ -9457,7 +9917,7 @@
                       </a:r>
                     </a:p>
                   </a:txBody>
-                  <a:tcPr anchor="ctr" marL="73152" marR="73152" marT="27432" marB="27432">
+                  <a:tcPr marL="73152" marR="73152" marT="27432" marB="27432" anchor="ctr">
                     <a:solidFill>
                       <a:srgbClr val="F2F6FB"/>
                     </a:solidFill>
@@ -9465,7 +9925,7 @@
                 </a:tc>
                 <a:tc>
                   <a:txBody>
-                    <a:bodyPr wrap="square"/>
+                    <a:bodyPr/>
                     <a:lstStyle/>
                     <a:p>
                       <a:pPr algn="l"/>
@@ -9480,7 +9940,7 @@
                       </a:r>
                     </a:p>
                   </a:txBody>
-                  <a:tcPr anchor="ctr" marL="73152" marR="73152" marT="27432" marB="27432">
+                  <a:tcPr marL="73152" marR="73152" marT="27432" marB="27432" anchor="ctr">
                     <a:solidFill>
                       <a:srgbClr val="F2F6FB"/>
                     </a:solidFill>
@@ -9488,7 +9948,7 @@
                 </a:tc>
                 <a:tc>
                   <a:txBody>
-                    <a:bodyPr wrap="square"/>
+                    <a:bodyPr/>
                     <a:lstStyle/>
                     <a:p>
                       <a:pPr algn="l"/>
@@ -9503,7 +9963,7 @@
                       </a:r>
                     </a:p>
                   </a:txBody>
-                  <a:tcPr anchor="ctr" marL="73152" marR="73152" marT="27432" marB="27432">
+                  <a:tcPr marL="73152" marR="73152" marT="27432" marB="27432" anchor="ctr">
                     <a:solidFill>
                       <a:srgbClr val="F2F6FB"/>
                     </a:solidFill>
@@ -9511,7 +9971,7 @@
                 </a:tc>
                 <a:tc>
                   <a:txBody>
-                    <a:bodyPr wrap="square"/>
+                    <a:bodyPr/>
                     <a:lstStyle/>
                     <a:p>
                       <a:pPr algn="l"/>
@@ -9526,17 +9986,22 @@
                       </a:r>
                     </a:p>
                   </a:txBody>
-                  <a:tcPr anchor="ctr" marL="73152" marR="73152" marT="27432" marB="27432">
+                  <a:tcPr marL="73152" marR="73152" marT="27432" marB="27432" anchor="ctr">
                     <a:solidFill>
                       <a:srgbClr val="F2F6FB"/>
                     </a:solidFill>
                   </a:tcPr>
                 </a:tc>
+                <a:extLst>
+                  <a:ext uri="{0D108BD9-81ED-4DB2-BD59-A6C34878D82A}">
+                    <a16:rowId xmlns:a16="http://schemas.microsoft.com/office/drawing/2014/main" val="10002"/>
+                  </a:ext>
+                </a:extLst>
               </a:tr>
               <a:tr h="457200">
                 <a:tc>
                   <a:txBody>
-                    <a:bodyPr wrap="square"/>
+                    <a:bodyPr/>
                     <a:lstStyle/>
                     <a:p>
                       <a:pPr algn="ctr"/>
@@ -9551,7 +10016,7 @@
                       </a:r>
                     </a:p>
                   </a:txBody>
-                  <a:tcPr anchor="ctr" marL="73152" marR="73152" marT="27432" marB="27432">
+                  <a:tcPr marL="73152" marR="73152" marT="27432" marB="27432" anchor="ctr">
                     <a:solidFill>
                       <a:srgbClr val="FFFFFF"/>
                     </a:solidFill>
@@ -9559,7 +10024,7 @@
                 </a:tc>
                 <a:tc>
                   <a:txBody>
-                    <a:bodyPr wrap="square"/>
+                    <a:bodyPr/>
                     <a:lstStyle/>
                     <a:p>
                       <a:pPr algn="l"/>
@@ -9574,7 +10039,7 @@
                       </a:r>
                     </a:p>
                   </a:txBody>
-                  <a:tcPr anchor="ctr" marL="73152" marR="73152" marT="27432" marB="27432">
+                  <a:tcPr marL="73152" marR="73152" marT="27432" marB="27432" anchor="ctr">
                     <a:solidFill>
                       <a:srgbClr val="FFFFFF"/>
                     </a:solidFill>
@@ -9582,7 +10047,7 @@
                 </a:tc>
                 <a:tc>
                   <a:txBody>
-                    <a:bodyPr wrap="square"/>
+                    <a:bodyPr/>
                     <a:lstStyle/>
                     <a:p>
                       <a:pPr algn="l"/>
@@ -9597,7 +10062,7 @@
                       </a:r>
                     </a:p>
                   </a:txBody>
-                  <a:tcPr anchor="ctr" marL="73152" marR="73152" marT="27432" marB="27432">
+                  <a:tcPr marL="73152" marR="73152" marT="27432" marB="27432" anchor="ctr">
                     <a:solidFill>
                       <a:srgbClr val="FFFFFF"/>
                     </a:solidFill>
@@ -9605,7 +10070,7 @@
                 </a:tc>
                 <a:tc>
                   <a:txBody>
-                    <a:bodyPr wrap="square"/>
+                    <a:bodyPr/>
                     <a:lstStyle/>
                     <a:p>
                       <a:pPr algn="l"/>
@@ -9620,17 +10085,22 @@
                       </a:r>
                     </a:p>
                   </a:txBody>
-                  <a:tcPr anchor="ctr" marL="73152" marR="73152" marT="27432" marB="27432">
+                  <a:tcPr marL="73152" marR="73152" marT="27432" marB="27432" anchor="ctr">
                     <a:solidFill>
                       <a:srgbClr val="FFFFFF"/>
                     </a:solidFill>
                   </a:tcPr>
                 </a:tc>
+                <a:extLst>
+                  <a:ext uri="{0D108BD9-81ED-4DB2-BD59-A6C34878D82A}">
+                    <a16:rowId xmlns:a16="http://schemas.microsoft.com/office/drawing/2014/main" val="10003"/>
+                  </a:ext>
+                </a:extLst>
               </a:tr>
               <a:tr h="457200">
                 <a:tc>
                   <a:txBody>
-                    <a:bodyPr wrap="square"/>
+                    <a:bodyPr/>
                     <a:lstStyle/>
                     <a:p>
                       <a:pPr algn="ctr"/>
@@ -9645,7 +10115,7 @@
                       </a:r>
                     </a:p>
                   </a:txBody>
-                  <a:tcPr anchor="ctr" marL="73152" marR="73152" marT="27432" marB="27432">
+                  <a:tcPr marL="73152" marR="73152" marT="27432" marB="27432" anchor="ctr">
                     <a:solidFill>
                       <a:srgbClr val="F2F6FB"/>
                     </a:solidFill>
@@ -9653,7 +10123,7 @@
                 </a:tc>
                 <a:tc>
                   <a:txBody>
-                    <a:bodyPr wrap="square"/>
+                    <a:bodyPr/>
                     <a:lstStyle/>
                     <a:p>
                       <a:pPr algn="l"/>
@@ -9668,7 +10138,7 @@
                       </a:r>
                     </a:p>
                   </a:txBody>
-                  <a:tcPr anchor="ctr" marL="73152" marR="73152" marT="27432" marB="27432">
+                  <a:tcPr marL="73152" marR="73152" marT="27432" marB="27432" anchor="ctr">
                     <a:solidFill>
                       <a:srgbClr val="F2F6FB"/>
                     </a:solidFill>
@@ -9676,7 +10146,7 @@
                 </a:tc>
                 <a:tc>
                   <a:txBody>
-                    <a:bodyPr wrap="square"/>
+                    <a:bodyPr/>
                     <a:lstStyle/>
                     <a:p>
                       <a:pPr algn="l"/>
@@ -9691,7 +10161,7 @@
                       </a:r>
                     </a:p>
                   </a:txBody>
-                  <a:tcPr anchor="ctr" marL="73152" marR="73152" marT="27432" marB="27432">
+                  <a:tcPr marL="73152" marR="73152" marT="27432" marB="27432" anchor="ctr">
                     <a:solidFill>
                       <a:srgbClr val="F2F6FB"/>
                     </a:solidFill>
@@ -9699,7 +10169,7 @@
                 </a:tc>
                 <a:tc>
                   <a:txBody>
-                    <a:bodyPr wrap="square"/>
+                    <a:bodyPr/>
                     <a:lstStyle/>
                     <a:p>
                       <a:pPr algn="l"/>
@@ -9714,17 +10184,22 @@
                       </a:r>
                     </a:p>
                   </a:txBody>
-                  <a:tcPr anchor="ctr" marL="73152" marR="73152" marT="27432" marB="27432">
+                  <a:tcPr marL="73152" marR="73152" marT="27432" marB="27432" anchor="ctr">
                     <a:solidFill>
                       <a:srgbClr val="F2F6FB"/>
                     </a:solidFill>
                   </a:tcPr>
                 </a:tc>
+                <a:extLst>
+                  <a:ext uri="{0D108BD9-81ED-4DB2-BD59-A6C34878D82A}">
+                    <a16:rowId xmlns:a16="http://schemas.microsoft.com/office/drawing/2014/main" val="10004"/>
+                  </a:ext>
+                </a:extLst>
               </a:tr>
               <a:tr h="457200">
                 <a:tc>
                   <a:txBody>
-                    <a:bodyPr wrap="square"/>
+                    <a:bodyPr/>
                     <a:lstStyle/>
                     <a:p>
                       <a:pPr algn="ctr"/>
@@ -9739,7 +10214,7 @@
                       </a:r>
                     </a:p>
                   </a:txBody>
-                  <a:tcPr anchor="ctr" marL="73152" marR="73152" marT="27432" marB="27432">
+                  <a:tcPr marL="73152" marR="73152" marT="27432" marB="27432" anchor="ctr">
                     <a:solidFill>
                       <a:srgbClr val="FFFFFF"/>
                     </a:solidFill>
@@ -9747,7 +10222,7 @@
                 </a:tc>
                 <a:tc>
                   <a:txBody>
-                    <a:bodyPr wrap="square"/>
+                    <a:bodyPr/>
                     <a:lstStyle/>
                     <a:p>
                       <a:pPr algn="l"/>
@@ -9762,7 +10237,7 @@
                       </a:r>
                     </a:p>
                   </a:txBody>
-                  <a:tcPr anchor="ctr" marL="73152" marR="73152" marT="27432" marB="27432">
+                  <a:tcPr marL="73152" marR="73152" marT="27432" marB="27432" anchor="ctr">
                     <a:solidFill>
                       <a:srgbClr val="FFFFFF"/>
                     </a:solidFill>
@@ -9770,7 +10245,7 @@
                 </a:tc>
                 <a:tc>
                   <a:txBody>
-                    <a:bodyPr wrap="square"/>
+                    <a:bodyPr/>
                     <a:lstStyle/>
                     <a:p>
                       <a:pPr algn="l"/>
@@ -9785,7 +10260,7 @@
                       </a:r>
                     </a:p>
                   </a:txBody>
-                  <a:tcPr anchor="ctr" marL="73152" marR="73152" marT="27432" marB="27432">
+                  <a:tcPr marL="73152" marR="73152" marT="27432" marB="27432" anchor="ctr">
                     <a:solidFill>
                       <a:srgbClr val="FFFFFF"/>
                     </a:solidFill>
@@ -9793,7 +10268,7 @@
                 </a:tc>
                 <a:tc>
                   <a:txBody>
-                    <a:bodyPr wrap="square"/>
+                    <a:bodyPr/>
                     <a:lstStyle/>
                     <a:p>
                       <a:pPr algn="l"/>
@@ -9808,17 +10283,22 @@
                       </a:r>
                     </a:p>
                   </a:txBody>
-                  <a:tcPr anchor="ctr" marL="73152" marR="73152" marT="27432" marB="27432">
+                  <a:tcPr marL="73152" marR="73152" marT="27432" marB="27432" anchor="ctr">
                     <a:solidFill>
                       <a:srgbClr val="FFFFFF"/>
                     </a:solidFill>
                   </a:tcPr>
                 </a:tc>
+                <a:extLst>
+                  <a:ext uri="{0D108BD9-81ED-4DB2-BD59-A6C34878D82A}">
+                    <a16:rowId xmlns:a16="http://schemas.microsoft.com/office/drawing/2014/main" val="10005"/>
+                  </a:ext>
+                </a:extLst>
               </a:tr>
               <a:tr h="457200">
                 <a:tc>
                   <a:txBody>
-                    <a:bodyPr wrap="square"/>
+                    <a:bodyPr/>
                     <a:lstStyle/>
                     <a:p>
                       <a:pPr algn="ctr"/>
@@ -9833,7 +10313,7 @@
                       </a:r>
                     </a:p>
                   </a:txBody>
-                  <a:tcPr anchor="ctr" marL="73152" marR="73152" marT="27432" marB="27432">
+                  <a:tcPr marL="73152" marR="73152" marT="27432" marB="27432" anchor="ctr">
                     <a:solidFill>
                       <a:srgbClr val="F2F6FB"/>
                     </a:solidFill>
@@ -9841,7 +10321,7 @@
                 </a:tc>
                 <a:tc>
                   <a:txBody>
-                    <a:bodyPr wrap="square"/>
+                    <a:bodyPr/>
                     <a:lstStyle/>
                     <a:p>
                       <a:pPr algn="l"/>
@@ -9856,7 +10336,7 @@
                       </a:r>
                     </a:p>
                   </a:txBody>
-                  <a:tcPr anchor="ctr" marL="73152" marR="73152" marT="27432" marB="27432">
+                  <a:tcPr marL="73152" marR="73152" marT="27432" marB="27432" anchor="ctr">
                     <a:solidFill>
                       <a:srgbClr val="F2F6FB"/>
                     </a:solidFill>
@@ -9864,7 +10344,7 @@
                 </a:tc>
                 <a:tc>
                   <a:txBody>
-                    <a:bodyPr wrap="square"/>
+                    <a:bodyPr/>
                     <a:lstStyle/>
                     <a:p>
                       <a:pPr algn="l"/>
@@ -9879,7 +10359,7 @@
                       </a:r>
                     </a:p>
                   </a:txBody>
-                  <a:tcPr anchor="ctr" marL="73152" marR="73152" marT="27432" marB="27432">
+                  <a:tcPr marL="73152" marR="73152" marT="27432" marB="27432" anchor="ctr">
                     <a:solidFill>
                       <a:srgbClr val="F2F6FB"/>
                     </a:solidFill>
@@ -9887,7 +10367,7 @@
                 </a:tc>
                 <a:tc>
                   <a:txBody>
-                    <a:bodyPr wrap="square"/>
+                    <a:bodyPr/>
                     <a:lstStyle/>
                     <a:p>
                       <a:pPr algn="l"/>
@@ -9902,12 +10382,17 @@
                       </a:r>
                     </a:p>
                   </a:txBody>
-                  <a:tcPr anchor="ctr" marL="73152" marR="73152" marT="27432" marB="27432">
+                  <a:tcPr marL="73152" marR="73152" marT="27432" marB="27432" anchor="ctr">
                     <a:solidFill>
                       <a:srgbClr val="F2F6FB"/>
                     </a:solidFill>
                   </a:tcPr>
                 </a:tc>
+                <a:extLst>
+                  <a:ext uri="{0D108BD9-81ED-4DB2-BD59-A6C34878D82A}">
+                    <a16:rowId xmlns:a16="http://schemas.microsoft.com/office/drawing/2014/main" val="10006"/>
+                  </a:ext>
+                </a:extLst>
               </a:tr>
             </a:tbl>
           </a:graphicData>
@@ -9958,6 +10443,7 @@
           <a:lstStyle/>
           <a:p>
             <a:pPr algn="ctr"/>
+            <a:endParaRPr/>
           </a:p>
         </p:txBody>
       </p:sp>
@@ -9978,7 +10464,7 @@
           <a:noFill/>
         </p:spPr>
         <p:txBody>
-          <a:bodyPr wrap="square" lIns="0" rIns="0" tIns="0" bIns="0" anchor="ctr">
+          <a:bodyPr wrap="square" lIns="0" tIns="0" rIns="0" bIns="0" anchor="ctr">
             <a:spAutoFit/>
           </a:bodyPr>
           <a:lstStyle/>
@@ -10018,7 +10504,7 @@
 </file>
 
 <file path=ppt/slides/slide5.xml><?xml version="1.0" encoding="utf-8"?>
-<p:sld xmlns:a="http://schemas.openxmlformats.org/drawingml/2006/main" xmlns:p="http://schemas.openxmlformats.org/presentationml/2006/main" xmlns:r="http://schemas.openxmlformats.org/officeDocument/2006/relationships">
+<p:sld xmlns:a="http://schemas.openxmlformats.org/drawingml/2006/main" xmlns:r="http://schemas.openxmlformats.org/officeDocument/2006/relationships" xmlns:p="http://schemas.openxmlformats.org/presentationml/2006/main">
   <p:cSld>
     <p:bg>
       <p:bgPr>
@@ -10034,7 +10520,14 @@
         <p:cNvGrpSpPr/>
         <p:nvPr/>
       </p:nvGrpSpPr>
-      <p:grpSpPr/>
+      <p:grpSpPr>
+        <a:xfrm>
+          <a:off x="0" y="0"/>
+          <a:ext cx="0" cy="0"/>
+          <a:chOff x="0" y="0"/>
+          <a:chExt cx="0" cy="0"/>
+        </a:xfrm>
+      </p:grpSpPr>
       <p:sp>
         <p:nvSpPr>
           <p:cNvPr id="2" name="Title"/>
@@ -10052,7 +10545,7 @@
           <a:noFill/>
         </p:spPr>
         <p:txBody>
-          <a:bodyPr wrap="square" lIns="0" rIns="0" tIns="0" bIns="0" anchor="ctr">
+          <a:bodyPr wrap="square" lIns="0" tIns="0" rIns="0" bIns="0" anchor="ctr">
             <a:spAutoFit/>
           </a:bodyPr>
           <a:lstStyle/>
@@ -10091,7 +10584,7 @@
           <a:noFill/>
         </p:spPr>
         <p:txBody>
-          <a:bodyPr wrap="square" lIns="0" rIns="0" tIns="0" bIns="0" anchor="ctr">
+          <a:bodyPr wrap="square" lIns="0" tIns="0" rIns="0" bIns="0" anchor="ctr">
             <a:spAutoFit/>
           </a:bodyPr>
           <a:lstStyle/>
@@ -10127,7 +10620,7 @@
         </p:xfrm>
         <a:graphic>
           <a:graphicData uri="http://schemas.openxmlformats.org/drawingml/2006/chart">
-            <c:chart xmlns:c="http://schemas.openxmlformats.org/drawingml/2006/chart" r:id="rId2"/>
+            <c:chart xmlns:c="http://schemas.openxmlformats.org/drawingml/2006/chart" xmlns:r="http://schemas.openxmlformats.org/officeDocument/2006/relationships" r:id="rId3"/>
           </a:graphicData>
         </a:graphic>
       </p:graphicFrame>
@@ -10176,6 +10669,7 @@
           <a:lstStyle/>
           <a:p>
             <a:pPr algn="ctr"/>
+            <a:endParaRPr/>
           </a:p>
         </p:txBody>
       </p:sp>
@@ -10196,7 +10690,7 @@
           <a:noFill/>
         </p:spPr>
         <p:txBody>
-          <a:bodyPr wrap="square" lIns="0" rIns="0" tIns="0" bIns="0" anchor="ctr">
+          <a:bodyPr wrap="square" lIns="0" tIns="0" rIns="0" bIns="0" anchor="ctr">
             <a:spAutoFit/>
           </a:bodyPr>
           <a:lstStyle/>
@@ -10235,12 +10729,12 @@
           <a:noFill/>
         </p:spPr>
         <p:txBody>
-          <a:bodyPr wrap="square" lIns="0" rIns="0" tIns="0" bIns="0" anchor="t">
+          <a:bodyPr wrap="square" lIns="0" tIns="0" rIns="0" bIns="0" anchor="t">
             <a:spAutoFit/>
           </a:bodyPr>
           <a:lstStyle/>
           <a:p>
-            <a:pPr algn="l" marL="285750" indent="-285750">
+            <a:pPr marL="285750" indent="-285750" algn="l">
               <a:spcAft>
                 <a:spcPts val="800"/>
               </a:spcAft>
@@ -10258,7 +10752,7 @@
             </a:r>
           </a:p>
           <a:p>
-            <a:pPr algn="l" marL="285750" indent="-285750">
+            <a:pPr marL="285750" indent="-285750" algn="l">
               <a:spcAft>
                 <a:spcPts val="800"/>
               </a:spcAft>
@@ -10322,6 +10816,7 @@
           <a:lstStyle/>
           <a:p>
             <a:pPr algn="ctr"/>
+            <a:endParaRPr/>
           </a:p>
         </p:txBody>
       </p:sp>
@@ -10342,7 +10837,7 @@
           <a:noFill/>
         </p:spPr>
         <p:txBody>
-          <a:bodyPr wrap="square" lIns="0" rIns="0" tIns="0" bIns="0" anchor="ctr">
+          <a:bodyPr wrap="square" lIns="0" tIns="0" rIns="0" bIns="0" anchor="ctr">
             <a:spAutoFit/>
           </a:bodyPr>
           <a:lstStyle/>
@@ -10381,12 +10876,12 @@
           <a:noFill/>
         </p:spPr>
         <p:txBody>
-          <a:bodyPr wrap="square" lIns="0" rIns="0" tIns="0" bIns="0" anchor="t">
+          <a:bodyPr wrap="square" lIns="0" tIns="0" rIns="0" bIns="0" anchor="t">
             <a:spAutoFit/>
           </a:bodyPr>
           <a:lstStyle/>
           <a:p>
-            <a:pPr algn="l" marL="285750" indent="-285750">
+            <a:pPr marL="285750" indent="-285750" algn="l">
               <a:spcAft>
                 <a:spcPts val="800"/>
               </a:spcAft>
@@ -10404,7 +10899,7 @@
             </a:r>
           </a:p>
           <a:p>
-            <a:pPr algn="l" marL="285750" indent="-285750">
+            <a:pPr marL="285750" indent="-285750" algn="l">
               <a:spcAft>
                 <a:spcPts val="800"/>
               </a:spcAft>
@@ -10432,7 +10927,7 @@
 </file>
 
 <file path=ppt/slides/slide6.xml><?xml version="1.0" encoding="utf-8"?>
-<p:sld xmlns:a="http://schemas.openxmlformats.org/drawingml/2006/main" xmlns:p="http://schemas.openxmlformats.org/presentationml/2006/main" xmlns:r="http://schemas.openxmlformats.org/officeDocument/2006/relationships">
+<p:sld xmlns:a="http://schemas.openxmlformats.org/drawingml/2006/main" xmlns:r="http://schemas.openxmlformats.org/officeDocument/2006/relationships" xmlns:p="http://schemas.openxmlformats.org/presentationml/2006/main">
   <p:cSld>
     <p:bg>
       <p:bgPr>
@@ -10448,7 +10943,14 @@
         <p:cNvGrpSpPr/>
         <p:nvPr/>
       </p:nvGrpSpPr>
-      <p:grpSpPr/>
+      <p:grpSpPr>
+        <a:xfrm>
+          <a:off x="0" y="0"/>
+          <a:ext cx="0" cy="0"/>
+          <a:chOff x="0" y="0"/>
+          <a:chExt cx="0" cy="0"/>
+        </a:xfrm>
+      </p:grpSpPr>
       <p:sp>
         <p:nvSpPr>
           <p:cNvPr id="2" name="Title"/>
@@ -10466,7 +10968,7 @@
           <a:noFill/>
         </p:spPr>
         <p:txBody>
-          <a:bodyPr wrap="square" lIns="0" rIns="0" tIns="0" bIns="0" anchor="ctr">
+          <a:bodyPr wrap="square" lIns="0" tIns="0" rIns="0" bIns="0" anchor="ctr">
             <a:spAutoFit/>
           </a:bodyPr>
           <a:lstStyle/>
@@ -10505,7 +11007,7 @@
           <a:noFill/>
         </p:spPr>
         <p:txBody>
-          <a:bodyPr wrap="square" lIns="0" rIns="0" tIns="0" bIns="0" anchor="ctr">
+          <a:bodyPr wrap="square" lIns="0" tIns="0" rIns="0" bIns="0" anchor="ctr">
             <a:spAutoFit/>
           </a:bodyPr>
           <a:lstStyle/>
@@ -10544,7 +11046,7 @@
           <a:noFill/>
         </p:spPr>
         <p:txBody>
-          <a:bodyPr wrap="square" lIns="0" rIns="0" tIns="0" bIns="0" anchor="t">
+          <a:bodyPr wrap="square" lIns="0" tIns="0" rIns="0" bIns="0" anchor="t">
             <a:spAutoFit/>
           </a:bodyPr>
           <a:lstStyle/>
@@ -10583,7 +11085,7 @@
           <a:noFill/>
         </p:spPr>
         <p:txBody>
-          <a:bodyPr wrap="square" lIns="0" rIns="0" tIns="0" bIns="0" anchor="t">
+          <a:bodyPr wrap="square" lIns="0" tIns="0" rIns="0" bIns="0" anchor="t">
             <a:spAutoFit/>
           </a:bodyPr>
           <a:lstStyle/>
@@ -10646,7 +11148,7 @@
           </a:fontRef>
         </p:style>
         <p:txBody>
-          <a:bodyPr rtlCol="0" anchor="ctr" wrap="square" lIns="73152" rIns="73152"/>
+          <a:bodyPr wrap="square" lIns="73152" rIns="73152" rtlCol="0" anchor="ctr"/>
           <a:lstStyle/>
           <a:p>
             <a:pPr algn="ctr"/>
@@ -10727,7 +11229,7 @@
           </a:fontRef>
         </p:style>
         <p:txBody>
-          <a:bodyPr rtlCol="0" anchor="ctr" wrap="square" lIns="73152" rIns="73152"/>
+          <a:bodyPr wrap="square" lIns="73152" rIns="73152" rtlCol="0" anchor="ctr"/>
           <a:lstStyle/>
           <a:p>
             <a:pPr algn="ctr"/>
@@ -10844,7 +11346,7 @@
           </a:fontRef>
         </p:style>
         <p:txBody>
-          <a:bodyPr rtlCol="0" anchor="ctr" wrap="square" lIns="73152" rIns="73152"/>
+          <a:bodyPr wrap="square" lIns="73152" rIns="73152" rtlCol="0" anchor="ctr"/>
           <a:lstStyle/>
           <a:p>
             <a:pPr algn="ctr"/>
@@ -10949,7 +11451,7 @@
           </a:fontRef>
         </p:style>
         <p:txBody>
-          <a:bodyPr rtlCol="0" anchor="ctr" wrap="square" lIns="73152" rIns="73152"/>
+          <a:bodyPr wrap="square" lIns="73152" rIns="73152" rtlCol="0" anchor="ctr"/>
           <a:lstStyle/>
           <a:p>
             <a:pPr algn="ctr"/>
@@ -11066,7 +11568,7 @@
           </a:fontRef>
         </p:style>
         <p:txBody>
-          <a:bodyPr rtlCol="0" anchor="ctr" wrap="square" lIns="73152" rIns="73152"/>
+          <a:bodyPr wrap="square" lIns="73152" rIns="73152" rtlCol="0" anchor="ctr"/>
           <a:lstStyle/>
           <a:p>
             <a:pPr algn="ctr"/>
@@ -11147,7 +11649,7 @@
           </a:fontRef>
         </p:style>
         <p:txBody>
-          <a:bodyPr rtlCol="0" anchor="ctr" wrap="square" lIns="73152" rIns="73152"/>
+          <a:bodyPr wrap="square" lIns="73152" rIns="73152" rtlCol="0" anchor="ctr"/>
           <a:lstStyle/>
           <a:p>
             <a:pPr algn="ctr"/>
@@ -11264,7 +11766,7 @@
           </a:fontRef>
         </p:style>
         <p:txBody>
-          <a:bodyPr rtlCol="0" anchor="ctr" wrap="square" lIns="73152" rIns="73152"/>
+          <a:bodyPr wrap="square" lIns="73152" rIns="73152" rtlCol="0" anchor="ctr"/>
           <a:lstStyle/>
           <a:p>
             <a:pPr algn="ctr"/>
@@ -11369,7 +11871,7 @@
           </a:fontRef>
         </p:style>
         <p:txBody>
-          <a:bodyPr rtlCol="0" anchor="ctr" wrap="square" lIns="73152" rIns="73152"/>
+          <a:bodyPr wrap="square" lIns="73152" rIns="73152" rtlCol="0" anchor="ctr"/>
           <a:lstStyle/>
           <a:p>
             <a:pPr algn="ctr"/>
@@ -11474,7 +11976,7 @@
           </a:fontRef>
         </p:style>
         <p:txBody>
-          <a:bodyPr rtlCol="0" anchor="ctr" wrap="square" lIns="73152" rIns="73152"/>
+          <a:bodyPr wrap="square" lIns="73152" rIns="73152" rtlCol="0" anchor="ctr"/>
           <a:lstStyle/>
           <a:p>
             <a:pPr algn="ctr"/>
@@ -11603,7 +12105,7 @@
           <a:noFill/>
         </p:spPr>
         <p:txBody>
-          <a:bodyPr wrap="square" lIns="0" rIns="0" tIns="0" bIns="0" anchor="t">
+          <a:bodyPr wrap="square" lIns="0" tIns="0" rIns="0" bIns="0" anchor="t">
             <a:spAutoFit/>
           </a:bodyPr>
           <a:lstStyle/>
@@ -11634,7 +12136,7 @@
 </file>
 
 <file path=ppt/slides/slide7.xml><?xml version="1.0" encoding="utf-8"?>
-<p:sld xmlns:a="http://schemas.openxmlformats.org/drawingml/2006/main" xmlns:p="http://schemas.openxmlformats.org/presentationml/2006/main" xmlns:r="http://schemas.openxmlformats.org/officeDocument/2006/relationships">
+<p:sld xmlns:a="http://schemas.openxmlformats.org/drawingml/2006/main" xmlns:r="http://schemas.openxmlformats.org/officeDocument/2006/relationships" xmlns:p="http://schemas.openxmlformats.org/presentationml/2006/main">
   <p:cSld>
     <p:bg>
       <p:bgPr>
@@ -11650,7 +12152,14 @@
         <p:cNvGrpSpPr/>
         <p:nvPr/>
       </p:nvGrpSpPr>
-      <p:grpSpPr/>
+      <p:grpSpPr>
+        <a:xfrm>
+          <a:off x="0" y="0"/>
+          <a:ext cx="0" cy="0"/>
+          <a:chOff x="0" y="0"/>
+          <a:chExt cx="0" cy="0"/>
+        </a:xfrm>
+      </p:grpSpPr>
       <p:sp>
         <p:nvSpPr>
           <p:cNvPr id="2" name="Title"/>
@@ -11668,7 +12177,7 @@
           <a:noFill/>
         </p:spPr>
         <p:txBody>
-          <a:bodyPr wrap="square" lIns="0" rIns="0" tIns="0" bIns="0" anchor="ctr">
+          <a:bodyPr wrap="square" lIns="0" tIns="0" rIns="0" bIns="0" anchor="ctr">
             <a:spAutoFit/>
           </a:bodyPr>
           <a:lstStyle/>
@@ -11707,7 +12216,7 @@
           <a:noFill/>
         </p:spPr>
         <p:txBody>
-          <a:bodyPr wrap="square" lIns="0" rIns="0" tIns="0" bIns="0" anchor="ctr">
+          <a:bodyPr wrap="square" lIns="0" tIns="0" rIns="0" bIns="0" anchor="ctr">
             <a:spAutoFit/>
           </a:bodyPr>
           <a:lstStyle/>
@@ -11738,7 +12247,7 @@
           <p:nvPr/>
         </p:nvPicPr>
         <p:blipFill>
-          <a:blip r:embed="rId2"/>
+          <a:blip r:embed="rId3"/>
           <a:stretch>
             <a:fillRect/>
           </a:stretch>
@@ -11770,7 +12279,7 @@
           <a:noFill/>
         </p:spPr>
         <p:txBody>
-          <a:bodyPr wrap="square" lIns="0" rIns="0" tIns="0" bIns="0" anchor="t">
+          <a:bodyPr wrap="square" lIns="0" tIns="0" rIns="0" bIns="0" anchor="t">
             <a:spAutoFit/>
           </a:bodyPr>
           <a:lstStyle/>
@@ -11811,12 +12320,48 @@
                 <a:tableStyleId>{5940675A-B579-460E-94D1-54222C63F5DA}</a:tableStyleId>
               </a:tblPr>
               <a:tblGrid>
-                <a:gridCol w="1863852"/>
-                <a:gridCol w="1863852"/>
-                <a:gridCol w="1863852"/>
-                <a:gridCol w="1863852"/>
-                <a:gridCol w="1863852"/>
-                <a:gridCol w="1863852"/>
+                <a:gridCol w="1863852">
+                  <a:extLst>
+                    <a:ext uri="{9D8B030D-6E8A-4147-A177-3AD203B41FA5}">
+                      <a16:colId xmlns:a16="http://schemas.microsoft.com/office/drawing/2014/main" val="20000"/>
+                    </a:ext>
+                  </a:extLst>
+                </a:gridCol>
+                <a:gridCol w="1863852">
+                  <a:extLst>
+                    <a:ext uri="{9D8B030D-6E8A-4147-A177-3AD203B41FA5}">
+                      <a16:colId xmlns:a16="http://schemas.microsoft.com/office/drawing/2014/main" val="20001"/>
+                    </a:ext>
+                  </a:extLst>
+                </a:gridCol>
+                <a:gridCol w="1863852">
+                  <a:extLst>
+                    <a:ext uri="{9D8B030D-6E8A-4147-A177-3AD203B41FA5}">
+                      <a16:colId xmlns:a16="http://schemas.microsoft.com/office/drawing/2014/main" val="20002"/>
+                    </a:ext>
+                  </a:extLst>
+                </a:gridCol>
+                <a:gridCol w="1863852">
+                  <a:extLst>
+                    <a:ext uri="{9D8B030D-6E8A-4147-A177-3AD203B41FA5}">
+                      <a16:colId xmlns:a16="http://schemas.microsoft.com/office/drawing/2014/main" val="20003"/>
+                    </a:ext>
+                  </a:extLst>
+                </a:gridCol>
+                <a:gridCol w="1863852">
+                  <a:extLst>
+                    <a:ext uri="{9D8B030D-6E8A-4147-A177-3AD203B41FA5}">
+                      <a16:colId xmlns:a16="http://schemas.microsoft.com/office/drawing/2014/main" val="20004"/>
+                    </a:ext>
+                  </a:extLst>
+                </a:gridCol>
+                <a:gridCol w="1863852">
+                  <a:extLst>
+                    <a:ext uri="{9D8B030D-6E8A-4147-A177-3AD203B41FA5}">
+                      <a16:colId xmlns:a16="http://schemas.microsoft.com/office/drawing/2014/main" val="20005"/>
+                    </a:ext>
+                  </a:extLst>
+                </a:gridCol>
               </a:tblGrid>
               <a:tr h="457200">
                 <a:tc>
@@ -11957,6 +12502,11 @@
                     </a:solidFill>
                   </a:tcPr>
                 </a:tc>
+                <a:extLst>
+                  <a:ext uri="{0D108BD9-81ED-4DB2-BD59-A6C34878D82A}">
+                    <a16:rowId xmlns:a16="http://schemas.microsoft.com/office/drawing/2014/main" val="10000"/>
+                  </a:ext>
+                </a:extLst>
               </a:tr>
               <a:tr h="457200">
                 <a:tc>
@@ -12097,6 +12647,11 @@
                     </a:solidFill>
                   </a:tcPr>
                 </a:tc>
+                <a:extLst>
+                  <a:ext uri="{0D108BD9-81ED-4DB2-BD59-A6C34878D82A}">
+                    <a16:rowId xmlns:a16="http://schemas.microsoft.com/office/drawing/2014/main" val="10001"/>
+                  </a:ext>
+                </a:extLst>
               </a:tr>
               <a:tr h="457200">
                 <a:tc>
@@ -12237,6 +12792,11 @@
                     </a:solidFill>
                   </a:tcPr>
                 </a:tc>
+                <a:extLst>
+                  <a:ext uri="{0D108BD9-81ED-4DB2-BD59-A6C34878D82A}">
+                    <a16:rowId xmlns:a16="http://schemas.microsoft.com/office/drawing/2014/main" val="10002"/>
+                  </a:ext>
+                </a:extLst>
               </a:tr>
               <a:tr h="457200">
                 <a:tc>
@@ -12377,6 +12937,11 @@
                     </a:solidFill>
                   </a:tcPr>
                 </a:tc>
+                <a:extLst>
+                  <a:ext uri="{0D108BD9-81ED-4DB2-BD59-A6C34878D82A}">
+                    <a16:rowId xmlns:a16="http://schemas.microsoft.com/office/drawing/2014/main" val="10003"/>
+                  </a:ext>
+                </a:extLst>
               </a:tr>
             </a:tbl>
           </a:graphicData>
@@ -12391,7 +12956,7 @@
 </file>
 
 <file path=ppt/slides/slide8.xml><?xml version="1.0" encoding="utf-8"?>
-<p:sld xmlns:a="http://schemas.openxmlformats.org/drawingml/2006/main" xmlns:p="http://schemas.openxmlformats.org/presentationml/2006/main" xmlns:r="http://schemas.openxmlformats.org/officeDocument/2006/relationships">
+<p:sld xmlns:a="http://schemas.openxmlformats.org/drawingml/2006/main" xmlns:r="http://schemas.openxmlformats.org/officeDocument/2006/relationships" xmlns:p="http://schemas.openxmlformats.org/presentationml/2006/main">
   <p:cSld>
     <p:bg>
       <p:bgPr>
@@ -12407,7 +12972,14 @@
         <p:cNvGrpSpPr/>
         <p:nvPr/>
       </p:nvGrpSpPr>
-      <p:grpSpPr/>
+      <p:grpSpPr>
+        <a:xfrm>
+          <a:off x="0" y="0"/>
+          <a:ext cx="0" cy="0"/>
+          <a:chOff x="0" y="0"/>
+          <a:chExt cx="0" cy="0"/>
+        </a:xfrm>
+      </p:grpSpPr>
       <p:sp>
         <p:nvSpPr>
           <p:cNvPr id="2" name="Title"/>
@@ -12425,7 +12997,7 @@
           <a:noFill/>
         </p:spPr>
         <p:txBody>
-          <a:bodyPr wrap="square" lIns="0" rIns="0" tIns="0" bIns="0" anchor="ctr">
+          <a:bodyPr wrap="square" lIns="0" tIns="0" rIns="0" bIns="0" anchor="ctr">
             <a:spAutoFit/>
           </a:bodyPr>
           <a:lstStyle/>
@@ -12464,7 +13036,7 @@
           <a:noFill/>
         </p:spPr>
         <p:txBody>
-          <a:bodyPr wrap="square" lIns="0" rIns="0" tIns="0" bIns="0" anchor="ctr">
+          <a:bodyPr wrap="square" lIns="0" tIns="0" rIns="0" bIns="0" anchor="ctr">
             <a:spAutoFit/>
           </a:bodyPr>
           <a:lstStyle/>
@@ -12495,7 +13067,7 @@
           <p:nvPr/>
         </p:nvPicPr>
         <p:blipFill>
-          <a:blip r:embed="rId2"/>
+          <a:blip r:embed="rId3"/>
           <a:stretch>
             <a:fillRect/>
           </a:stretch>
@@ -12527,7 +13099,7 @@
           <a:noFill/>
         </p:spPr>
         <p:txBody>
-          <a:bodyPr wrap="square" lIns="0" rIns="0" tIns="0" bIns="0" anchor="t">
+          <a:bodyPr wrap="square" lIns="0" tIns="0" rIns="0" bIns="0" anchor="t">
             <a:spAutoFit/>
           </a:bodyPr>
           <a:lstStyle/>
@@ -12594,6 +13166,7 @@
           <a:lstStyle/>
           <a:p>
             <a:pPr algn="ctr"/>
+            <a:endParaRPr/>
           </a:p>
         </p:txBody>
       </p:sp>
@@ -12614,7 +13187,7 @@
           <a:noFill/>
         </p:spPr>
         <p:txBody>
-          <a:bodyPr wrap="square" lIns="0" rIns="0" tIns="0" bIns="0" anchor="ctr">
+          <a:bodyPr wrap="square" lIns="0" tIns="0" rIns="0" bIns="0" anchor="ctr">
             <a:spAutoFit/>
           </a:bodyPr>
           <a:lstStyle/>
@@ -12653,7 +13226,7 @@
           <a:noFill/>
         </p:spPr>
         <p:txBody>
-          <a:bodyPr wrap="square" lIns="0" rIns="0" tIns="0" bIns="0" anchor="t">
+          <a:bodyPr wrap="square" lIns="0" tIns="0" rIns="0" bIns="0" anchor="t">
             <a:spAutoFit/>
           </a:bodyPr>
           <a:lstStyle/>
@@ -12720,6 +13293,7 @@
           <a:lstStyle/>
           <a:p>
             <a:pPr algn="ctr"/>
+            <a:endParaRPr/>
           </a:p>
         </p:txBody>
       </p:sp>
@@ -12740,7 +13314,7 @@
           <a:noFill/>
         </p:spPr>
         <p:txBody>
-          <a:bodyPr wrap="square" lIns="0" rIns="0" tIns="0" bIns="0" anchor="ctr">
+          <a:bodyPr wrap="square" lIns="0" tIns="0" rIns="0" bIns="0" anchor="ctr">
             <a:spAutoFit/>
           </a:bodyPr>
           <a:lstStyle/>
@@ -12779,7 +13353,7 @@
           <a:noFill/>
         </p:spPr>
         <p:txBody>
-          <a:bodyPr wrap="square" lIns="0" rIns="0" tIns="0" bIns="0" anchor="t">
+          <a:bodyPr wrap="square" lIns="0" tIns="0" rIns="0" bIns="0" anchor="t">
             <a:spAutoFit/>
           </a:bodyPr>
           <a:lstStyle/>
@@ -12846,6 +13420,7 @@
           <a:lstStyle/>
           <a:p>
             <a:pPr algn="ctr"/>
+            <a:endParaRPr/>
           </a:p>
         </p:txBody>
       </p:sp>
@@ -12866,7 +13441,7 @@
           <a:noFill/>
         </p:spPr>
         <p:txBody>
-          <a:bodyPr wrap="square" lIns="0" rIns="0" tIns="0" bIns="0" anchor="ctr">
+          <a:bodyPr wrap="square" lIns="0" tIns="0" rIns="0" bIns="0" anchor="ctr">
             <a:spAutoFit/>
           </a:bodyPr>
           <a:lstStyle/>
@@ -12905,7 +13480,7 @@
           <a:noFill/>
         </p:spPr>
         <p:txBody>
-          <a:bodyPr wrap="square" lIns="0" rIns="0" tIns="0" bIns="0" anchor="t">
+          <a:bodyPr wrap="square" lIns="0" tIns="0" rIns="0" bIns="0" anchor="t">
             <a:spAutoFit/>
           </a:bodyPr>
           <a:lstStyle/>
@@ -12944,7 +13519,7 @@
           <a:noFill/>
         </p:spPr>
         <p:txBody>
-          <a:bodyPr wrap="square" lIns="0" rIns="0" tIns="0" bIns="0" anchor="t">
+          <a:bodyPr wrap="square" lIns="0" tIns="0" rIns="0" bIns="0" anchor="t">
             <a:spAutoFit/>
           </a:bodyPr>
           <a:lstStyle/>
@@ -12975,7 +13550,7 @@
 </file>
 
 <file path=ppt/slides/slide9.xml><?xml version="1.0" encoding="utf-8"?>
-<p:sld xmlns:a="http://schemas.openxmlformats.org/drawingml/2006/main" xmlns:p="http://schemas.openxmlformats.org/presentationml/2006/main" xmlns:r="http://schemas.openxmlformats.org/officeDocument/2006/relationships">
+<p:sld xmlns:a="http://schemas.openxmlformats.org/drawingml/2006/main" xmlns:r="http://schemas.openxmlformats.org/officeDocument/2006/relationships" xmlns:p="http://schemas.openxmlformats.org/presentationml/2006/main">
   <p:cSld>
     <p:bg>
       <p:bgPr>
@@ -12991,7 +13566,14 @@
         <p:cNvGrpSpPr/>
         <p:nvPr/>
       </p:nvGrpSpPr>
-      <p:grpSpPr/>
+      <p:grpSpPr>
+        <a:xfrm>
+          <a:off x="0" y="0"/>
+          <a:ext cx="0" cy="0"/>
+          <a:chOff x="0" y="0"/>
+          <a:chExt cx="0" cy="0"/>
+        </a:xfrm>
+      </p:grpSpPr>
       <p:sp>
         <p:nvSpPr>
           <p:cNvPr id="2" name="Title"/>
@@ -13009,7 +13591,7 @@
           <a:noFill/>
         </p:spPr>
         <p:txBody>
-          <a:bodyPr wrap="square" lIns="0" rIns="0" tIns="0" bIns="0" anchor="ctr">
+          <a:bodyPr wrap="square" lIns="0" tIns="0" rIns="0" bIns="0" anchor="ctr">
             <a:spAutoFit/>
           </a:bodyPr>
           <a:lstStyle/>
@@ -13048,7 +13630,7 @@
           <a:noFill/>
         </p:spPr>
         <p:txBody>
-          <a:bodyPr wrap="square" lIns="0" rIns="0" tIns="0" bIns="0" anchor="ctr">
+          <a:bodyPr wrap="square" lIns="0" tIns="0" rIns="0" bIns="0" anchor="ctr">
             <a:spAutoFit/>
           </a:bodyPr>
           <a:lstStyle/>
@@ -13115,6 +13697,7 @@
           <a:lstStyle/>
           <a:p>
             <a:pPr algn="ctr"/>
+            <a:endParaRPr/>
           </a:p>
         </p:txBody>
       </p:sp>
@@ -13135,7 +13718,7 @@
           <a:noFill/>
         </p:spPr>
         <p:txBody>
-          <a:bodyPr wrap="square" lIns="0" rIns="0" tIns="0" bIns="0" anchor="ctr">
+          <a:bodyPr wrap="square" lIns="0" tIns="0" rIns="0" bIns="0" anchor="ctr">
             <a:spAutoFit/>
           </a:bodyPr>
           <a:lstStyle/>
@@ -13174,12 +13757,12 @@
           <a:noFill/>
         </p:spPr>
         <p:txBody>
-          <a:bodyPr wrap="square" lIns="0" rIns="0" tIns="0" bIns="0" anchor="t">
+          <a:bodyPr wrap="square" lIns="0" tIns="0" rIns="0" bIns="0" anchor="t">
             <a:spAutoFit/>
           </a:bodyPr>
           <a:lstStyle/>
           <a:p>
-            <a:pPr algn="l" marL="285750" indent="-285750">
+            <a:pPr marL="285750" indent="-285750" algn="l">
               <a:spcAft>
                 <a:spcPts val="800"/>
               </a:spcAft>
@@ -13197,7 +13780,7 @@
             </a:r>
           </a:p>
           <a:p>
-            <a:pPr algn="l" marL="285750" indent="-285750">
+            <a:pPr marL="285750" indent="-285750" algn="l">
               <a:spcAft>
                 <a:spcPts val="800"/>
               </a:spcAft>
@@ -13261,6 +13844,7 @@
           <a:lstStyle/>
           <a:p>
             <a:pPr algn="ctr"/>
+            <a:endParaRPr/>
           </a:p>
         </p:txBody>
       </p:sp>
@@ -13281,7 +13865,7 @@
           <a:noFill/>
         </p:spPr>
         <p:txBody>
-          <a:bodyPr wrap="square" lIns="0" rIns="0" tIns="0" bIns="0" anchor="ctr">
+          <a:bodyPr wrap="square" lIns="0" tIns="0" rIns="0" bIns="0" anchor="ctr">
             <a:spAutoFit/>
           </a:bodyPr>
           <a:lstStyle/>
@@ -13320,12 +13904,12 @@
           <a:noFill/>
         </p:spPr>
         <p:txBody>
-          <a:bodyPr wrap="square" lIns="0" rIns="0" tIns="0" bIns="0" anchor="t">
+          <a:bodyPr wrap="square" lIns="0" tIns="0" rIns="0" bIns="0" anchor="t">
             <a:spAutoFit/>
           </a:bodyPr>
           <a:lstStyle/>
           <a:p>
-            <a:pPr algn="l" marL="285750" indent="-285750">
+            <a:pPr marL="285750" indent="-285750" algn="l">
               <a:spcAft>
                 <a:spcPts val="800"/>
               </a:spcAft>
@@ -13343,7 +13927,7 @@
             </a:r>
           </a:p>
           <a:p>
-            <a:pPr algn="l" marL="285750" indent="-285750">
+            <a:pPr marL="285750" indent="-285750" algn="l">
               <a:spcAft>
                 <a:spcPts val="800"/>
               </a:spcAft>
@@ -13443,6 +14027,7 @@
           <a:lstStyle/>
           <a:p>
             <a:pPr algn="ctr"/>
+            <a:endParaRPr/>
           </a:p>
         </p:txBody>
       </p:sp>
@@ -13463,7 +14048,7 @@
           <a:noFill/>
         </p:spPr>
         <p:txBody>
-          <a:bodyPr wrap="square" lIns="0" rIns="0" tIns="0" bIns="0" anchor="ctr">
+          <a:bodyPr wrap="square" lIns="0" tIns="0" rIns="0" bIns="0" anchor="ctr">
             <a:spAutoFit/>
           </a:bodyPr>
           <a:lstStyle/>
@@ -13502,12 +14087,12 @@
           <a:noFill/>
         </p:spPr>
         <p:txBody>
-          <a:bodyPr wrap="square" lIns="0" rIns="0" tIns="0" bIns="0" anchor="t">
+          <a:bodyPr wrap="square" lIns="0" tIns="0" rIns="0" bIns="0" anchor="t">
             <a:spAutoFit/>
           </a:bodyPr>
           <a:lstStyle/>
           <a:p>
-            <a:pPr algn="l" marL="285750" indent="-285750">
+            <a:pPr marL="285750" indent="-285750" algn="l">
               <a:spcAft>
                 <a:spcPts val="800"/>
               </a:spcAft>
@@ -13525,7 +14110,7 @@
             </a:r>
           </a:p>
           <a:p>
-            <a:pPr algn="l" marL="285750" indent="-285750">
+            <a:pPr marL="285750" indent="-285750" algn="l">
               <a:spcAft>
                 <a:spcPts val="800"/>
               </a:spcAft>
@@ -13625,6 +14210,7 @@
           <a:lstStyle/>
           <a:p>
             <a:pPr algn="ctr"/>
+            <a:endParaRPr/>
           </a:p>
         </p:txBody>
       </p:sp>
@@ -13645,7 +14231,7 @@
           <a:noFill/>
         </p:spPr>
         <p:txBody>
-          <a:bodyPr wrap="square" lIns="0" rIns="0" tIns="0" bIns="0" anchor="ctr">
+          <a:bodyPr wrap="square" lIns="0" tIns="0" rIns="0" bIns="0" anchor="ctr">
             <a:spAutoFit/>
           </a:bodyPr>
           <a:lstStyle/>
@@ -13684,12 +14270,12 @@
           <a:noFill/>
         </p:spPr>
         <p:txBody>
-          <a:bodyPr wrap="square" lIns="0" rIns="0" tIns="0" bIns="0" anchor="t">
+          <a:bodyPr wrap="square" lIns="0" tIns="0" rIns="0" bIns="0" anchor="t">
             <a:spAutoFit/>
           </a:bodyPr>
           <a:lstStyle/>
           <a:p>
-            <a:pPr algn="l" marL="285750" indent="-285750">
+            <a:pPr marL="285750" indent="-285750" algn="l">
               <a:spcAft>
                 <a:spcPts val="800"/>
               </a:spcAft>
@@ -13707,7 +14293,7 @@
             </a:r>
           </a:p>
           <a:p>
-            <a:pPr algn="l" marL="285750" indent="-285750">
+            <a:pPr marL="285750" indent="-285750" algn="l">
               <a:spcAft>
                 <a:spcPts val="800"/>
               </a:spcAft>

</xml_diff>